<commit_message>
fix: Error de etiquetación (no concordaban los límites de los rangos
</commit_message>
<xml_diff>
--- a/TFG_Chollos/TFG_Presentacion_final.pptx
+++ b/TFG_Chollos/TFG_Presentacion_final.pptx
@@ -10734,7 +10734,7 @@
                 <a:ea typeface="Calibri" pitchFamily="34" charset="-122"/>
                 <a:cs typeface="Calibri" pitchFamily="34" charset="-120"/>
               </a:rPr>
-              <a:t>0.85 ≤ ratio &lt; 0.99</a:t>
+              <a:t>0.85 ≤ ratio &lt; 0.97</a:t>
             </a:r>
             <a:endParaRPr lang="en-US" sz="800" dirty="0"/>
           </a:p>
@@ -10751,7 +10751,7 @@
                 <a:ea typeface="Calibri" pitchFamily="34" charset="-122"/>
                 <a:cs typeface="Calibri" pitchFamily="34" charset="-120"/>
               </a:rPr>
-              <a:t>1–15% más barato</a:t>
+              <a:t>3–15% más barato</a:t>
             </a:r>
             <a:endParaRPr lang="en-US" sz="800" dirty="0"/>
           </a:p>
@@ -10856,7 +10856,7 @@
                 <a:ea typeface="Calibri" pitchFamily="34" charset="-122"/>
                 <a:cs typeface="Calibri" pitchFamily="34" charset="-120"/>
               </a:rPr>
-              <a:t>0.99 ≤ ratio ≤ 1.01</a:t>
+              <a:t>0.97 ≤ ratio ≤ 1.03</a:t>
             </a:r>
             <a:endParaRPr lang="en-US" sz="800" dirty="0"/>
           </a:p>
@@ -10873,7 +10873,7 @@
                 <a:ea typeface="Calibri" pitchFamily="34" charset="-122"/>
                 <a:cs typeface="Calibri" pitchFamily="34" charset="-120"/>
               </a:rPr>
-              <a:t>precio dentro del ±1%</a:t>
+              <a:t>precio dentro del ±3%</a:t>
             </a:r>
             <a:endParaRPr lang="en-US" sz="800" dirty="0"/>
           </a:p>
@@ -10978,7 +10978,7 @@
                 <a:ea typeface="Calibri" pitchFamily="34" charset="-122"/>
                 <a:cs typeface="Calibri" pitchFamily="34" charset="-120"/>
               </a:rPr>
-              <a:t>ratio &gt; 1.05</a:t>
+              <a:t>ratio &gt; 1.03</a:t>
             </a:r>
             <a:endParaRPr lang="en-US" sz="800" dirty="0"/>
           </a:p>
@@ -10995,7 +10995,7 @@
                 <a:ea typeface="Calibri" pitchFamily="34" charset="-122"/>
                 <a:cs typeface="Calibri" pitchFamily="34" charset="-120"/>
               </a:rPr>
-              <a:t>más de un 5% por encima</a:t>
+              <a:t>más de un 3% por encima</a:t>
             </a:r>
             <a:endParaRPr lang="en-US" sz="800" dirty="0"/>
           </a:p>
@@ -11296,7 +11296,7 @@
                 <a:ea typeface="Consolas" pitchFamily="34" charset="-122"/>
                 <a:cs typeface="Consolas" pitchFamily="34" charset="-120"/>
               </a:rPr>
-              <a:t>    (ratio &gt;= 0.85) &amp; (ratio &lt; 0.99),   # chollo</a:t>
+              <a:t>    (ratio &gt;= 0.85) &amp; (ratio &lt; 0.97),   # chollo</a:t>
             </a:r>
             <a:endParaRPr lang="en-US" sz="800" dirty="0"/>
           </a:p>
@@ -11313,7 +11313,7 @@
                 <a:ea typeface="Consolas" pitchFamily="34" charset="-122"/>
                 <a:cs typeface="Consolas" pitchFamily="34" charset="-120"/>
               </a:rPr>
-              <a:t>    (ratio &gt;= 0.99) &amp; (ratio &lt;= 1.01),  # normal</a:t>
+              <a:t>    (ratio &gt;= 0.97) &amp; (ratio &lt;= 1.03),  # normal</a:t>
             </a:r>
             <a:endParaRPr lang="en-US" sz="800" dirty="0"/>
           </a:p>
@@ -11330,7 +11330,7 @@
                 <a:ea typeface="Consolas" pitchFamily="34" charset="-122"/>
                 <a:cs typeface="Consolas" pitchFamily="34" charset="-120"/>
               </a:rPr>
-              <a:t>    ratio &gt; 1.05                         # inflado</a:t>
+              <a:t>    ratio &gt; 1.03                         # inflado</a:t>
             </a:r>
             <a:endParaRPr lang="en-US" sz="800" dirty="0"/>
           </a:p>

</xml_diff>

<commit_message>
update: Estilo nuevo slice
</commit_message>
<xml_diff>
--- a/TFG_Chollos/TFG_Presentacion_final.pptx
+++ b/TFG_Chollos/TFG_Presentacion_final.pptx
@@ -5,7 +5,7 @@
     <p:sldMasterId id="2147483648" r:id="rId1"/>
   </p:sldMasterIdLst>
   <p:notesMasterIdLst>
-    <p:notesMasterId r:id="rId25"/>
+    <p:notesMasterId r:id="rId26"/>
   </p:notesMasterIdLst>
   <p:sldIdLst>
     <p:sldId id="256" r:id="rId2"/>
@@ -21,16 +21,17 @@
     <p:sldId id="276" r:id="rId12"/>
     <p:sldId id="274" r:id="rId13"/>
     <p:sldId id="279" r:id="rId14"/>
-    <p:sldId id="277" r:id="rId15"/>
-    <p:sldId id="262" r:id="rId16"/>
-    <p:sldId id="264" r:id="rId17"/>
-    <p:sldId id="270" r:id="rId18"/>
-    <p:sldId id="271" r:id="rId19"/>
-    <p:sldId id="275" r:id="rId20"/>
-    <p:sldId id="263" r:id="rId21"/>
-    <p:sldId id="265" r:id="rId22"/>
-    <p:sldId id="268" r:id="rId23"/>
-    <p:sldId id="269" r:id="rId24"/>
+    <p:sldId id="280" r:id="rId15"/>
+    <p:sldId id="277" r:id="rId16"/>
+    <p:sldId id="262" r:id="rId17"/>
+    <p:sldId id="264" r:id="rId18"/>
+    <p:sldId id="270" r:id="rId19"/>
+    <p:sldId id="271" r:id="rId20"/>
+    <p:sldId id="275" r:id="rId21"/>
+    <p:sldId id="263" r:id="rId22"/>
+    <p:sldId id="265" r:id="rId23"/>
+    <p:sldId id="268" r:id="rId24"/>
+    <p:sldId id="269" r:id="rId25"/>
   </p:sldIdLst>
   <p:sldSz cx="9144000" cy="5143500" type="screen16x9"/>
   <p:notesSz cx="5143500" cy="9144000"/>
@@ -408,7 +409,7 @@
           <a:p>
             <a:fld id="{F7021451-1387-4CA6-816F-3879F97B5CBC}" type="slidenum">
               <a:rPr lang="en-US"/>
-              <a:t>20</a:t>
+              <a:t>21</a:t>
             </a:fld>
             <a:endParaRPr lang="en-US"/>
           </a:p>
@@ -492,7 +493,7 @@
           <a:p>
             <a:fld id="{F7021451-1387-4CA6-816F-3879F97B5CBC}" type="slidenum">
               <a:rPr lang="en-US"/>
-              <a:t>21</a:t>
+              <a:t>22</a:t>
             </a:fld>
             <a:endParaRPr lang="en-US"/>
           </a:p>
@@ -576,7 +577,7 @@
           <a:p>
             <a:fld id="{F7021451-1387-4CA6-816F-3879F97B5CBC}" type="slidenum">
               <a:rPr lang="en-US"/>
-              <a:t>22</a:t>
+              <a:t>23</a:t>
             </a:fld>
             <a:endParaRPr lang="en-US"/>
           </a:p>
@@ -660,7 +661,7 @@
           <a:p>
             <a:fld id="{F7021451-1387-4CA6-816F-3879F97B5CBC}" type="slidenum">
               <a:rPr lang="en-US"/>
-              <a:t>23</a:t>
+              <a:t>24</a:t>
             </a:fld>
             <a:endParaRPr lang="en-US"/>
           </a:p>
@@ -1248,7 +1249,7 @@
           <a:p>
             <a:fld id="{F7021451-1387-4CA6-816F-3879F97B5CBC}" type="slidenum">
               <a:rPr lang="en-US"/>
-              <a:t>15</a:t>
+              <a:t>16</a:t>
             </a:fld>
             <a:endParaRPr lang="en-US"/>
           </a:p>
@@ -1332,7 +1333,7 @@
           <a:p>
             <a:fld id="{F7021451-1387-4CA6-816F-3879F97B5CBC}" type="slidenum">
               <a:rPr lang="en-US"/>
-              <a:t>16</a:t>
+              <a:t>17</a:t>
             </a:fld>
             <a:endParaRPr lang="en-US"/>
           </a:p>
@@ -6802,6 +6803,637 @@
     <p:bg>
       <p:bgPr>
         <a:solidFill>
+          <a:srgbClr val="1A2E4A"/>
+        </a:solidFill>
+        <a:effectLst/>
+      </p:bgPr>
+    </p:bg>
+    <p:spTree>
+      <p:nvGrpSpPr>
+        <p:cNvPr id="1" name=""/>
+        <p:cNvGrpSpPr/>
+        <p:nvPr/>
+      </p:nvGrpSpPr>
+      <p:grpSpPr>
+        <a:xfrm>
+          <a:off x="0" y="0"/>
+          <a:ext cx="0" cy="0"/>
+          <a:chOff x="0" y="0"/>
+          <a:chExt cx="0" cy="0"/>
+        </a:xfrm>
+      </p:grpSpPr>
+      <p:sp>
+        <p:nvSpPr>
+          <p:cNvPr id="2" name="Rectangle 1"/>
+          <p:cNvSpPr/>
+          <p:nvPr/>
+        </p:nvSpPr>
+        <p:spPr>
+          <a:xfrm>
+            <a:off x="0" y="0"/>
+            <a:ext cx="9144000" cy="54864"/>
+          </a:xfrm>
+          <a:prstGeom prst="rect">
+            <a:avLst/>
+          </a:prstGeom>
+          <a:solidFill>
+            <a:srgbClr val="D4A843"/>
+          </a:solidFill>
+          <a:ln>
+            <a:noFill/>
+          </a:ln>
+          <a:effectLst/>
+        </p:spPr>
+        <p:style>
+          <a:lnRef idx="1">
+            <a:schemeClr val="accent1"/>
+          </a:lnRef>
+          <a:fillRef idx="3">
+            <a:schemeClr val="accent1"/>
+          </a:fillRef>
+          <a:effectRef idx="2">
+            <a:schemeClr val="accent1"/>
+          </a:effectRef>
+          <a:fontRef idx="minor">
+            <a:schemeClr val="lt1"/>
+          </a:fontRef>
+        </p:style>
+        <p:txBody>
+          <a:bodyPr rtlCol="0" anchor="ctr"/>
+          <a:lstStyle/>
+          <a:p>
+            <a:pPr algn="ctr"/>
+            <a:endParaRPr/>
+          </a:p>
+        </p:txBody>
+      </p:sp>
+      <p:sp>
+        <p:nvSpPr>
+          <p:cNvPr id="3" name="TextBox 2"/>
+          <p:cNvSpPr txBox="1"/>
+          <p:nvPr/>
+        </p:nvSpPr>
+        <p:spPr>
+          <a:xfrm>
+            <a:off x="457200" y="109728"/>
+            <a:ext cx="8229600" cy="457200"/>
+          </a:xfrm>
+          <a:prstGeom prst="rect">
+            <a:avLst/>
+          </a:prstGeom>
+          <a:noFill/>
+        </p:spPr>
+        <p:txBody>
+          <a:bodyPr wrap="square" lIns="0" tIns="0" rIns="0" bIns="0">
+            <a:spAutoFit/>
+          </a:bodyPr>
+          <a:lstStyle/>
+          <a:p>
+            <a:pPr algn="l"/>
+            <a:r>
+              <a:rPr sz="2400" b="1">
+                <a:solidFill>
+                  <a:srgbClr val="FFFFFF"/>
+                </a:solidFill>
+                <a:latin typeface="Calibri"/>
+              </a:rPr>
+              <a:t>Interoperabilidad Python ↔ R · rpy2 + ggplot2</a:t>
+            </a:r>
+          </a:p>
+        </p:txBody>
+      </p:sp>
+      <p:sp>
+        <p:nvSpPr>
+          <p:cNvPr id="4" name="TextBox 3"/>
+          <p:cNvSpPr txBox="1"/>
+          <p:nvPr/>
+        </p:nvSpPr>
+        <p:spPr>
+          <a:xfrm>
+            <a:off x="457200" y="603504"/>
+            <a:ext cx="8229600" cy="274320"/>
+          </a:xfrm>
+          <a:prstGeom prst="rect">
+            <a:avLst/>
+          </a:prstGeom>
+          <a:noFill/>
+        </p:spPr>
+        <p:txBody>
+          <a:bodyPr wrap="square" lIns="0" tIns="0" rIns="0" bIns="0">
+            <a:spAutoFit/>
+          </a:bodyPr>
+          <a:lstStyle/>
+          <a:p>
+            <a:pPr algn="l"/>
+            <a:r>
+              <a:rPr sz="1000" b="0">
+                <a:solidFill>
+                  <a:srgbClr val="F0C060"/>
+                </a:solidFill>
+                <a:latin typeface="Consolas"/>
+              </a:rPr>
+              <a:t>Graficos/r_integration.py  ·  Python envía el DataFrame a R  ·  R genera el gráfico ggplot2 y devuelve los bins</a:t>
+            </a:r>
+          </a:p>
+        </p:txBody>
+      </p:sp>
+      <p:pic>
+        <p:nvPicPr>
+          <p:cNvPr id="5" name="Picture 4" descr="eda_hist_precios_comparativa.png"/>
+          <p:cNvPicPr>
+            <a:picLocks noChangeAspect="1"/>
+          </p:cNvPicPr>
+          <p:nvPr/>
+        </p:nvPicPr>
+        <p:blipFill>
+          <a:blip r:embed="rId2"/>
+          <a:stretch>
+            <a:fillRect/>
+          </a:stretch>
+        </p:blipFill>
+        <p:spPr>
+          <a:xfrm>
+            <a:off x="457200" y="855939"/>
+            <a:ext cx="8229600" cy="2745486"/>
+          </a:xfrm>
+          <a:prstGeom prst="rect">
+            <a:avLst/>
+          </a:prstGeom>
+        </p:spPr>
+      </p:pic>
+      <p:pic>
+        <p:nvPicPr>
+          <p:cNvPr id="6" name="Picture 5" descr="eda_hist_precios_r.png"/>
+          <p:cNvPicPr>
+            <a:picLocks noChangeAspect="1"/>
+          </p:cNvPicPr>
+          <p:nvPr/>
+        </p:nvPicPr>
+        <p:blipFill>
+          <a:blip r:embed="rId3"/>
+          <a:stretch>
+            <a:fillRect/>
+          </a:stretch>
+        </p:blipFill>
+        <p:spPr>
+          <a:xfrm>
+            <a:off x="457200" y="3767328"/>
+            <a:ext cx="1905977" cy="1058875"/>
+          </a:xfrm>
+          <a:prstGeom prst="rect">
+            <a:avLst/>
+          </a:prstGeom>
+        </p:spPr>
+      </p:pic>
+      <p:sp>
+        <p:nvSpPr>
+          <p:cNvPr id="7" name="TextBox 6"/>
+          <p:cNvSpPr txBox="1"/>
+          <p:nvPr/>
+        </p:nvSpPr>
+        <p:spPr>
+          <a:xfrm>
+            <a:off x="2413604" y="4032301"/>
+            <a:ext cx="1776259" cy="430631"/>
+          </a:xfrm>
+          <a:prstGeom prst="rect">
+            <a:avLst/>
+          </a:prstGeom>
+          <a:noFill/>
+        </p:spPr>
+        <p:txBody>
+          <a:bodyPr wrap="square" lIns="0" tIns="0" rIns="0" bIns="0" anchor="ctr">
+            <a:spAutoFit/>
+          </a:bodyPr>
+          <a:lstStyle/>
+          <a:p>
+            <a:pPr algn="l">
+              <a:lnSpc>
+                <a:spcPct val="105000"/>
+              </a:lnSpc>
+            </a:pPr>
+            <a:r>
+              <a:rPr sz="1000" b="1" dirty="0">
+                <a:solidFill>
+                  <a:srgbClr val="F0C060"/>
+                </a:solidFill>
+                <a:latin typeface="Calibri"/>
+              </a:rPr>
+              <a:t>ggplot2 (R)</a:t>
+            </a:r>
+          </a:p>
+          <a:p>
+            <a:pPr algn="l">
+              <a:lnSpc>
+                <a:spcPct val="105000"/>
+              </a:lnSpc>
+            </a:pPr>
+            <a:r>
+              <a:rPr sz="850" b="0" dirty="0" err="1">
+                <a:solidFill>
+                  <a:srgbClr val="CBD5E1"/>
+                </a:solidFill>
+                <a:latin typeface="Calibri"/>
+              </a:rPr>
+              <a:t>Mismo</a:t>
+            </a:r>
+            <a:r>
+              <a:rPr sz="850" b="0" dirty="0">
+                <a:solidFill>
+                  <a:srgbClr val="CBD5E1"/>
+                </a:solidFill>
+                <a:latin typeface="Calibri"/>
+              </a:rPr>
+              <a:t> </a:t>
+            </a:r>
+            <a:r>
+              <a:rPr sz="850" b="0" dirty="0" err="1">
+                <a:solidFill>
+                  <a:srgbClr val="CBD5E1"/>
+                </a:solidFill>
+                <a:latin typeface="Calibri"/>
+              </a:rPr>
+              <a:t>histograma</a:t>
+            </a:r>
+            <a:r>
+              <a:rPr sz="850" b="0" dirty="0">
+                <a:solidFill>
+                  <a:srgbClr val="CBD5E1"/>
+                </a:solidFill>
+                <a:latin typeface="Calibri"/>
+              </a:rPr>
+              <a:t> </a:t>
+            </a:r>
+            <a:r>
+              <a:rPr sz="850" b="0" dirty="0" err="1">
+                <a:solidFill>
+                  <a:srgbClr val="CBD5E1"/>
+                </a:solidFill>
+                <a:latin typeface="Calibri"/>
+              </a:rPr>
+              <a:t>generado</a:t>
+            </a:r>
+            <a:r>
+              <a:rPr sz="850" b="0" dirty="0">
+                <a:solidFill>
+                  <a:srgbClr val="CBD5E1"/>
+                </a:solidFill>
+                <a:latin typeface="Calibri"/>
+              </a:rPr>
+              <a:t> </a:t>
+            </a:r>
+            <a:r>
+              <a:rPr sz="850" b="0" dirty="0" err="1">
+                <a:solidFill>
+                  <a:srgbClr val="CBD5E1"/>
+                </a:solidFill>
+                <a:latin typeface="Calibri"/>
+              </a:rPr>
+              <a:t>en</a:t>
+            </a:r>
+            <a:r>
+              <a:rPr sz="850" b="0" dirty="0">
+                <a:solidFill>
+                  <a:srgbClr val="CBD5E1"/>
+                </a:solidFill>
+                <a:latin typeface="Calibri"/>
+              </a:rPr>
+              <a:t> R con </a:t>
+            </a:r>
+          </a:p>
+          <a:p>
+            <a:pPr algn="l">
+              <a:lnSpc>
+                <a:spcPct val="105000"/>
+              </a:lnSpc>
+            </a:pPr>
+            <a:r>
+              <a:rPr sz="850" b="1" dirty="0" err="1">
+                <a:solidFill>
+                  <a:srgbClr val="F0C060"/>
+                </a:solidFill>
+                <a:latin typeface="Consolas"/>
+              </a:rPr>
+              <a:t>ggsave</a:t>
+            </a:r>
+            <a:r>
+              <a:rPr sz="850" b="1" dirty="0">
+                <a:solidFill>
+                  <a:srgbClr val="F0C060"/>
+                </a:solidFill>
+                <a:latin typeface="Consolas"/>
+              </a:rPr>
+              <a:t>()</a:t>
+            </a:r>
+            <a:r>
+              <a:rPr sz="850" b="0" dirty="0">
+                <a:solidFill>
+                  <a:srgbClr val="CBD5E1"/>
+                </a:solidFill>
+                <a:latin typeface="Calibri"/>
+              </a:rPr>
+              <a:t> y </a:t>
+            </a:r>
+            <a:r>
+              <a:rPr sz="850" b="0" dirty="0" err="1">
+                <a:solidFill>
+                  <a:srgbClr val="CBD5E1"/>
+                </a:solidFill>
+                <a:latin typeface="Calibri"/>
+              </a:rPr>
+              <a:t>devuelto</a:t>
+            </a:r>
+            <a:r>
+              <a:rPr sz="850" b="0" dirty="0">
+                <a:solidFill>
+                  <a:srgbClr val="CBD5E1"/>
+                </a:solidFill>
+                <a:latin typeface="Calibri"/>
+              </a:rPr>
+              <a:t> </a:t>
+            </a:r>
+            <a:r>
+              <a:rPr sz="850" b="0" dirty="0" err="1">
+                <a:solidFill>
+                  <a:srgbClr val="CBD5E1"/>
+                </a:solidFill>
+                <a:latin typeface="Calibri"/>
+              </a:rPr>
+              <a:t>como</a:t>
+            </a:r>
+            <a:r>
+              <a:rPr sz="850" b="0" dirty="0">
+                <a:solidFill>
+                  <a:srgbClr val="CBD5E1"/>
+                </a:solidFill>
+                <a:latin typeface="Calibri"/>
+              </a:rPr>
+              <a:t> imagen.</a:t>
+            </a:r>
+          </a:p>
+        </p:txBody>
+      </p:sp>
+      <p:sp>
+        <p:nvSpPr>
+          <p:cNvPr id="8" name="Rectangle 7"/>
+          <p:cNvSpPr/>
+          <p:nvPr/>
+        </p:nvSpPr>
+        <p:spPr>
+          <a:xfrm>
+            <a:off x="4572000" y="3813048"/>
+            <a:ext cx="4230014" cy="201168"/>
+          </a:xfrm>
+          <a:prstGeom prst="rect">
+            <a:avLst/>
+          </a:prstGeom>
+          <a:solidFill>
+            <a:srgbClr val="2A5080"/>
+          </a:solidFill>
+          <a:ln>
+            <a:noFill/>
+          </a:ln>
+          <a:effectLst/>
+        </p:spPr>
+        <p:style>
+          <a:lnRef idx="1">
+            <a:schemeClr val="accent1"/>
+          </a:lnRef>
+          <a:fillRef idx="3">
+            <a:schemeClr val="accent1"/>
+          </a:fillRef>
+          <a:effectRef idx="2">
+            <a:schemeClr val="accent1"/>
+          </a:effectRef>
+          <a:fontRef idx="minor">
+            <a:schemeClr val="lt1"/>
+          </a:fontRef>
+        </p:style>
+        <p:txBody>
+          <a:bodyPr rtlCol="0" anchor="ctr"/>
+          <a:lstStyle/>
+          <a:p>
+            <a:pPr algn="ctr"/>
+            <a:endParaRPr/>
+          </a:p>
+        </p:txBody>
+      </p:sp>
+      <p:sp>
+        <p:nvSpPr>
+          <p:cNvPr id="9" name="TextBox 8"/>
+          <p:cNvSpPr txBox="1"/>
+          <p:nvPr/>
+        </p:nvSpPr>
+        <p:spPr>
+          <a:xfrm>
+            <a:off x="4626864" y="3813048"/>
+            <a:ext cx="4120286" cy="201168"/>
+          </a:xfrm>
+          <a:prstGeom prst="rect">
+            <a:avLst/>
+          </a:prstGeom>
+          <a:noFill/>
+        </p:spPr>
+        <p:txBody>
+          <a:bodyPr wrap="square" lIns="0" tIns="0" rIns="0" bIns="0" anchor="ctr">
+            <a:spAutoFit/>
+          </a:bodyPr>
+          <a:lstStyle/>
+          <a:p>
+            <a:pPr algn="l"/>
+            <a:r>
+              <a:rPr sz="900" b="1">
+                <a:solidFill>
+                  <a:srgbClr val="F0C060"/>
+                </a:solidFill>
+                <a:latin typeface="Consolas"/>
+              </a:rPr>
+              <a:t>r_integration.py — Python → R con rpy2</a:t>
+            </a:r>
+          </a:p>
+        </p:txBody>
+      </p:sp>
+      <p:sp>
+        <p:nvSpPr>
+          <p:cNvPr id="10" name="Rectangle 9"/>
+          <p:cNvSpPr/>
+          <p:nvPr/>
+        </p:nvSpPr>
+        <p:spPr>
+          <a:xfrm>
+            <a:off x="4572000" y="4014216"/>
+            <a:ext cx="4230014" cy="603503"/>
+          </a:xfrm>
+          <a:prstGeom prst="rect">
+            <a:avLst/>
+          </a:prstGeom>
+          <a:solidFill>
+            <a:srgbClr val="0D1117"/>
+          </a:solidFill>
+          <a:ln>
+            <a:noFill/>
+          </a:ln>
+          <a:effectLst/>
+        </p:spPr>
+        <p:style>
+          <a:lnRef idx="1">
+            <a:schemeClr val="accent1"/>
+          </a:lnRef>
+          <a:fillRef idx="3">
+            <a:schemeClr val="accent1"/>
+          </a:fillRef>
+          <a:effectRef idx="2">
+            <a:schemeClr val="accent1"/>
+          </a:effectRef>
+          <a:fontRef idx="minor">
+            <a:schemeClr val="lt1"/>
+          </a:fontRef>
+        </p:style>
+        <p:txBody>
+          <a:bodyPr rtlCol="0" anchor="ctr"/>
+          <a:lstStyle/>
+          <a:p>
+            <a:pPr algn="ctr"/>
+            <a:endParaRPr/>
+          </a:p>
+        </p:txBody>
+      </p:sp>
+      <p:sp>
+        <p:nvSpPr>
+          <p:cNvPr id="11" name="TextBox 10"/>
+          <p:cNvSpPr txBox="1"/>
+          <p:nvPr/>
+        </p:nvSpPr>
+        <p:spPr>
+          <a:xfrm>
+            <a:off x="4645152" y="4059936"/>
+            <a:ext cx="4083710" cy="530351"/>
+          </a:xfrm>
+          <a:prstGeom prst="rect">
+            <a:avLst/>
+          </a:prstGeom>
+          <a:noFill/>
+        </p:spPr>
+        <p:txBody>
+          <a:bodyPr wrap="square" lIns="0" tIns="0" rIns="0" bIns="0">
+            <a:spAutoFit/>
+          </a:bodyPr>
+          <a:lstStyle/>
+          <a:p>
+            <a:pPr algn="l">
+              <a:lnSpc>
+                <a:spcPct val="105000"/>
+              </a:lnSpc>
+            </a:pPr>
+            <a:r>
+              <a:rPr sz="800" b="0">
+                <a:solidFill>
+                  <a:srgbClr val="E2E8F0"/>
+                </a:solidFill>
+                <a:latin typeface="Consolas"/>
+              </a:rPr>
+              <a:t>ro.globalenv['df_r'] = pandas2ri.py2rpy(df[['precio']])</a:t>
+            </a:r>
+          </a:p>
+          <a:p>
+            <a:pPr algn="l">
+              <a:lnSpc>
+                <a:spcPct val="105000"/>
+              </a:lnSpc>
+            </a:pPr>
+            <a:r>
+              <a:rPr sz="800" b="0">
+                <a:solidFill>
+                  <a:srgbClr val="E2E8F0"/>
+                </a:solidFill>
+                <a:latin typeface="Consolas"/>
+              </a:rPr>
+              <a:t>ro.r('hist_data &lt;- hist(df_r$precio, plot=FALSE)')</a:t>
+            </a:r>
+          </a:p>
+          <a:p>
+            <a:pPr algn="l">
+              <a:lnSpc>
+                <a:spcPct val="105000"/>
+              </a:lnSpc>
+            </a:pPr>
+            <a:r>
+              <a:rPr sz="800" b="0">
+                <a:solidFill>
+                  <a:srgbClr val="E2E8F0"/>
+                </a:solidFill>
+                <a:latin typeface="Consolas"/>
+              </a:rPr>
+              <a:t>breaks = list(ro.r('hist_data$breaks'))</a:t>
+            </a:r>
+          </a:p>
+          <a:p>
+            <a:pPr algn="l">
+              <a:lnSpc>
+                <a:spcPct val="105000"/>
+              </a:lnSpc>
+            </a:pPr>
+            <a:r>
+              <a:rPr sz="800" b="0">
+                <a:solidFill>
+                  <a:srgbClr val="E2E8F0"/>
+                </a:solidFill>
+                <a:latin typeface="Consolas"/>
+              </a:rPr>
+              <a:t>counts = list(ro.r('hist_data$counts'))</a:t>
+            </a:r>
+          </a:p>
+        </p:txBody>
+      </p:sp>
+      <p:sp>
+        <p:nvSpPr>
+          <p:cNvPr id="12" name="TextBox 11"/>
+          <p:cNvSpPr txBox="1"/>
+          <p:nvPr/>
+        </p:nvSpPr>
+        <p:spPr>
+          <a:xfrm>
+            <a:off x="457200" y="4826203"/>
+            <a:ext cx="7772400" cy="201168"/>
+          </a:xfrm>
+          <a:prstGeom prst="rect">
+            <a:avLst/>
+          </a:prstGeom>
+          <a:noFill/>
+        </p:spPr>
+        <p:txBody>
+          <a:bodyPr wrap="square" lIns="0" tIns="0" rIns="0" bIns="0">
+            <a:spAutoFit/>
+          </a:bodyPr>
+          <a:lstStyle/>
+          <a:p>
+            <a:pPr algn="l"/>
+            <a:r>
+              <a:rPr sz="800" b="0">
+                <a:solidFill>
+                  <a:srgbClr val="4A6080"/>
+                </a:solidFill>
+                <a:latin typeface="Calibri"/>
+              </a:rPr>
+              <a:t>TFG · Detector de Chollos en Andalucía · Mario Jiménez · Universidad de Sevilla · 2025–2026</a:t>
+            </a:r>
+          </a:p>
+        </p:txBody>
+      </p:sp>
+    </p:spTree>
+  </p:cSld>
+  <p:clrMapOvr>
+    <a:masterClrMapping/>
+  </p:clrMapOvr>
+</p:sld>
+</file>
+
+<file path=ppt/slides/slide15.xml><?xml version="1.0" encoding="utf-8"?>
+<p:sld xmlns:a="http://schemas.openxmlformats.org/drawingml/2006/main" xmlns:r="http://schemas.openxmlformats.org/officeDocument/2006/relationships" xmlns:p="http://schemas.openxmlformats.org/presentationml/2006/main">
+  <p:cSld>
+    <p:bg>
+      <p:bgPr>
+        <a:solidFill>
           <a:srgbClr val="F4F8FC"/>
         </a:solidFill>
         <a:effectLst/>
@@ -8144,7 +8776,7 @@
 </p:sld>
 </file>
 
-<file path=ppt/slides/slide15.xml><?xml version="1.0" encoding="utf-8"?>
+<file path=ppt/slides/slide16.xml><?xml version="1.0" encoding="utf-8"?>
 <p:sld xmlns:a="http://schemas.openxmlformats.org/drawingml/2006/main" xmlns:r="http://schemas.openxmlformats.org/officeDocument/2006/relationships" xmlns:p="http://schemas.openxmlformats.org/presentationml/2006/main">
   <p:cSld name="Slide 7">
     <p:bg>
@@ -9927,344 +10559,6 @@
               <a:buNone/>
             </a:pPr>
             <a:endParaRPr lang="en-US" sz="900" dirty="0"/>
-          </a:p>
-        </p:txBody>
-      </p:sp>
-    </p:spTree>
-  </p:cSld>
-  <p:clrMapOvr>
-    <a:masterClrMapping/>
-  </p:clrMapOvr>
-</p:sld>
-</file>
-
-<file path=ppt/slides/slide16.xml><?xml version="1.0" encoding="utf-8"?>
-<p:sld xmlns:a="http://schemas.openxmlformats.org/drawingml/2006/main" xmlns:r="http://schemas.openxmlformats.org/officeDocument/2006/relationships" xmlns:p="http://schemas.openxmlformats.org/presentationml/2006/main">
-  <p:cSld name="Slide 9">
-    <p:bg>
-      <p:bgPr>
-        <a:solidFill>
-          <a:srgbClr val="1A2E4A"/>
-        </a:solidFill>
-        <a:effectLst/>
-      </p:bgPr>
-    </p:bg>
-    <p:spTree>
-      <p:nvGrpSpPr>
-        <p:cNvPr id="1" name=""/>
-        <p:cNvGrpSpPr/>
-        <p:nvPr/>
-      </p:nvGrpSpPr>
-      <p:grpSpPr>
-        <a:xfrm>
-          <a:off x="0" y="0"/>
-          <a:ext cx="0" cy="0"/>
-          <a:chOff x="0" y="0"/>
-          <a:chExt cx="0" cy="0"/>
-        </a:xfrm>
-      </p:grpSpPr>
-      <p:sp>
-        <p:nvSpPr>
-          <p:cNvPr id="2" name="Shape 0"/>
-          <p:cNvSpPr/>
-          <p:nvPr/>
-        </p:nvSpPr>
-        <p:spPr>
-          <a:xfrm>
-            <a:off x="0" y="0"/>
-            <a:ext cx="9144000" cy="54864"/>
-          </a:xfrm>
-          <a:prstGeom prst="rect">
-            <a:avLst/>
-          </a:prstGeom>
-          <a:solidFill>
-            <a:srgbClr val="D4A843"/>
-          </a:solidFill>
-          <a:ln/>
-        </p:spPr>
-      </p:sp>
-      <p:sp>
-        <p:nvSpPr>
-          <p:cNvPr id="3" name="Text 1"/>
-          <p:cNvSpPr/>
-          <p:nvPr/>
-        </p:nvSpPr>
-        <p:spPr>
-          <a:xfrm>
-            <a:off x="457200" y="146304"/>
-            <a:ext cx="8229600" cy="457200"/>
-          </a:xfrm>
-          <a:prstGeom prst="rect">
-            <a:avLst/>
-          </a:prstGeom>
-          <a:noFill/>
-          <a:ln/>
-        </p:spPr>
-        <p:txBody>
-          <a:bodyPr wrap="square" lIns="0" tIns="0" rIns="0" bIns="0" rtlCol="0" anchor="ctr"/>
-          <a:lstStyle/>
-          <a:p>
-            <a:pPr marL="0" indent="0">
-              <a:buNone/>
-            </a:pPr>
-            <a:r>
-              <a:rPr lang="en-US" sz="2600" b="1" dirty="0">
-                <a:solidFill>
-                  <a:srgbClr val="FFFFFF"/>
-                </a:solidFill>
-                <a:latin typeface="Calibri" pitchFamily="34" charset="0"/>
-                <a:ea typeface="Calibri" pitchFamily="34" charset="-122"/>
-                <a:cs typeface="Calibri" pitchFamily="34" charset="-120"/>
-              </a:rPr>
-              <a:t>Visualización · </a:t>
-            </a:r>
-            <a:r>
-              <a:rPr lang="en-US" sz="2600" b="1" dirty="0" err="1">
-                <a:solidFill>
-                  <a:srgbClr val="FFFFFF"/>
-                </a:solidFill>
-                <a:latin typeface="Calibri" pitchFamily="34" charset="0"/>
-                <a:ea typeface="Calibri" pitchFamily="34" charset="-122"/>
-                <a:cs typeface="Calibri" pitchFamily="34" charset="-120"/>
-              </a:rPr>
-              <a:t>Corrplot</a:t>
-            </a:r>
-            <a:r>
-              <a:rPr lang="en-US" sz="2600" b="1" dirty="0">
-                <a:solidFill>
-                  <a:srgbClr val="FFFFFF"/>
-                </a:solidFill>
-                <a:latin typeface="Calibri" pitchFamily="34" charset="0"/>
-                <a:ea typeface="Calibri" pitchFamily="34" charset="-122"/>
-                <a:cs typeface="Calibri" pitchFamily="34" charset="-120"/>
-              </a:rPr>
-              <a:t> de </a:t>
-            </a:r>
-            <a:r>
-              <a:rPr lang="en-US" sz="2600" b="1" u="sng" dirty="0">
-                <a:solidFill>
-                  <a:srgbClr val="FFFFFF"/>
-                </a:solidFill>
-                <a:latin typeface="Calibri" pitchFamily="34" charset="0"/>
-                <a:ea typeface="Calibri" pitchFamily="34" charset="-122"/>
-                <a:cs typeface="Calibri" pitchFamily="34" charset="-120"/>
-              </a:rPr>
-              <a:t>R Studio</a:t>
-            </a:r>
-            <a:r>
-              <a:rPr lang="en-US" sz="2600" b="1" dirty="0">
-                <a:solidFill>
-                  <a:srgbClr val="FFFFFF"/>
-                </a:solidFill>
-                <a:latin typeface="Calibri" pitchFamily="34" charset="0"/>
-                <a:ea typeface="Calibri" pitchFamily="34" charset="-122"/>
-                <a:cs typeface="Calibri" pitchFamily="34" charset="-120"/>
-              </a:rPr>
-              <a:t> (1/3)</a:t>
-            </a:r>
-            <a:endParaRPr lang="en-US" sz="2600" dirty="0"/>
-          </a:p>
-        </p:txBody>
-      </p:sp>
-      <p:sp>
-        <p:nvSpPr>
-          <p:cNvPr id="4" name="Text 2"/>
-          <p:cNvSpPr/>
-          <p:nvPr/>
-        </p:nvSpPr>
-        <p:spPr>
-          <a:xfrm>
-            <a:off x="457200" y="562726"/>
-            <a:ext cx="8229600" cy="228600"/>
-          </a:xfrm>
-          <a:prstGeom prst="rect">
-            <a:avLst/>
-          </a:prstGeom>
-          <a:noFill/>
-          <a:ln/>
-        </p:spPr>
-        <p:txBody>
-          <a:bodyPr wrap="square" lIns="0" tIns="0" rIns="0" bIns="0" rtlCol="0" anchor="ctr"/>
-          <a:lstStyle/>
-          <a:p>
-            <a:pPr marL="0" indent="0">
-              <a:buNone/>
-            </a:pPr>
-            <a:r>
-              <a:rPr lang="en-US" sz="1000" dirty="0">
-                <a:solidFill>
-                  <a:srgbClr val="F0C060"/>
-                </a:solidFill>
-                <a:latin typeface="Consolas" pitchFamily="34" charset="0"/>
-                <a:ea typeface="Consolas" pitchFamily="34" charset="-122"/>
-                <a:cs typeface="Consolas" pitchFamily="34" charset="-120"/>
-              </a:rPr>
-              <a:t>Correlación lineal (Pearson) · dataset codificado numéricamente</a:t>
-            </a:r>
-            <a:endParaRPr lang="en-US" sz="1000" dirty="0"/>
-          </a:p>
-        </p:txBody>
-      </p:sp>
-      <p:pic>
-        <p:nvPicPr>
-          <p:cNvPr id="10" name="Image 0" descr="preencoded.png"/>
-          <p:cNvPicPr>
-            <a:picLocks noChangeAspect="1"/>
-          </p:cNvPicPr>
-          <p:nvPr/>
-        </p:nvPicPr>
-        <p:blipFill>
-          <a:blip r:embed="rId3"/>
-          <a:stretch>
-            <a:fillRect/>
-          </a:stretch>
-        </p:blipFill>
-        <p:spPr>
-          <a:xfrm>
-            <a:off x="1451819" y="982104"/>
-            <a:ext cx="6788377" cy="3940928"/>
-          </a:xfrm>
-          <a:prstGeom prst="rect">
-            <a:avLst/>
-          </a:prstGeom>
-        </p:spPr>
-      </p:pic>
-      <p:sp>
-        <p:nvSpPr>
-          <p:cNvPr id="33" name="Text 30"/>
-          <p:cNvSpPr/>
-          <p:nvPr/>
-        </p:nvSpPr>
-        <p:spPr>
-          <a:xfrm>
-            <a:off x="457200" y="4928616"/>
-            <a:ext cx="7772400" cy="201168"/>
-          </a:xfrm>
-          <a:prstGeom prst="rect">
-            <a:avLst/>
-          </a:prstGeom>
-          <a:noFill/>
-          <a:ln/>
-        </p:spPr>
-        <p:txBody>
-          <a:bodyPr wrap="square" lIns="0" tIns="0" rIns="0" bIns="0" rtlCol="0" anchor="ctr"/>
-          <a:lstStyle/>
-          <a:p>
-            <a:pPr marL="0" indent="0" algn="l">
-              <a:buNone/>
-            </a:pPr>
-            <a:r>
-              <a:rPr lang="en-US" sz="800" dirty="0">
-                <a:solidFill>
-                  <a:srgbClr val="4A6080"/>
-                </a:solidFill>
-                <a:latin typeface="Calibri" pitchFamily="34" charset="0"/>
-                <a:ea typeface="Calibri" pitchFamily="34" charset="-122"/>
-                <a:cs typeface="Calibri" pitchFamily="34" charset="-120"/>
-              </a:rPr>
-              <a:t>TFG · Detector de Chollos en Andalucía · Mario Jiménez · Universidad de Sevilla</a:t>
-            </a:r>
-            <a:endParaRPr lang="en-US" sz="800" dirty="0"/>
-          </a:p>
-        </p:txBody>
-      </p:sp>
-      <p:sp>
-        <p:nvSpPr>
-          <p:cNvPr id="34" name="Text 31"/>
-          <p:cNvSpPr/>
-          <p:nvPr/>
-        </p:nvSpPr>
-        <p:spPr>
-          <a:xfrm>
-            <a:off x="8595360" y="4754880"/>
-            <a:ext cx="365760" cy="228600"/>
-          </a:xfrm>
-          <a:prstGeom prst="rect">
-            <a:avLst/>
-          </a:prstGeom>
-          <a:noFill/>
-          <a:ln/>
-        </p:spPr>
-        <p:txBody>
-          <a:bodyPr wrap="square" lIns="0" tIns="0" rIns="0" bIns="0" rtlCol="0" anchor="ctr"/>
-          <a:lstStyle/>
-          <a:p>
-            <a:pPr marL="0" indent="0" algn="ctr">
-              <a:buNone/>
-            </a:pPr>
-            <a:endParaRPr lang="en-US" sz="900" dirty="0"/>
-          </a:p>
-        </p:txBody>
-      </p:sp>
-      <p:sp>
-        <p:nvSpPr>
-          <p:cNvPr id="50" name="LabelCorrplot"/>
-          <p:cNvSpPr/>
-          <p:nvPr/>
-        </p:nvSpPr>
-        <p:spPr>
-          <a:xfrm>
-            <a:off x="274680" y="786436"/>
-            <a:ext cx="8594640" cy="182880"/>
-          </a:xfrm>
-          <a:prstGeom prst="rect">
-            <a:avLst/>
-          </a:prstGeom>
-          <a:noFill/>
-          <a:ln/>
-        </p:spPr>
-        <p:txBody>
-          <a:bodyPr wrap="square" lIns="0" tIns="0" rIns="0" bIns="0" rtlCol="0" anchor="ctr"/>
-          <a:lstStyle/>
-          <a:p>
-            <a:pPr marL="0" indent="0">
-              <a:buNone/>
-            </a:pPr>
-            <a:r>
-              <a:rPr lang="es-ES" sz="900" b="1" dirty="0">
-                <a:solidFill>
-                  <a:srgbClr val="D4A843"/>
-                </a:solidFill>
-                <a:latin typeface="Calibri" pitchFamily="34" charset="0"/>
-              </a:rPr>
-              <a:t>📊  Pearson · </a:t>
-            </a:r>
-            <a:r>
-              <a:rPr lang="es-ES" sz="900" b="1" dirty="0">
-                <a:solidFill>
-                  <a:srgbClr val="FF0000"/>
-                </a:solidFill>
-                <a:latin typeface="Calibri" pitchFamily="34" charset="0"/>
-              </a:rPr>
-              <a:t>R Studio </a:t>
-            </a:r>
-            <a:r>
-              <a:rPr lang="es-ES" sz="900" b="1" dirty="0" err="1">
-                <a:solidFill>
-                  <a:srgbClr val="FF0000"/>
-                </a:solidFill>
-                <a:latin typeface="Calibri" pitchFamily="34" charset="0"/>
-              </a:rPr>
-              <a:t>corrplot</a:t>
-            </a:r>
-            <a:r>
-              <a:rPr lang="es-ES" sz="900" b="1" dirty="0">
-                <a:solidFill>
-                  <a:srgbClr val="FF0000"/>
-                </a:solidFill>
-                <a:latin typeface="Calibri" pitchFamily="34" charset="0"/>
-              </a:rPr>
-              <a:t> </a:t>
-            </a:r>
-            <a:r>
-              <a:rPr lang="es-ES" sz="900" b="1" dirty="0">
-                <a:solidFill>
-                  <a:srgbClr val="D4A843"/>
-                </a:solidFill>
-                <a:latin typeface="Calibri" pitchFamily="34" charset="0"/>
-              </a:rPr>
-              <a:t>· 30 variables · LabelEncoder + get_dummies</a:t>
-            </a:r>
           </a:p>
         </p:txBody>
       </p:sp>
@@ -10354,7 +10648,51 @@
                 <a:ea typeface="Calibri" pitchFamily="34" charset="-122"/>
                 <a:cs typeface="Calibri" pitchFamily="34" charset="-120"/>
               </a:rPr>
-              <a:t>Visualización de Datos  (2/3)</a:t>
+              <a:t>Visualización · </a:t>
+            </a:r>
+            <a:r>
+              <a:rPr lang="en-US" sz="2600" b="1" dirty="0" err="1">
+                <a:solidFill>
+                  <a:srgbClr val="FFFFFF"/>
+                </a:solidFill>
+                <a:latin typeface="Calibri" pitchFamily="34" charset="0"/>
+                <a:ea typeface="Calibri" pitchFamily="34" charset="-122"/>
+                <a:cs typeface="Calibri" pitchFamily="34" charset="-120"/>
+              </a:rPr>
+              <a:t>Corrplot</a:t>
+            </a:r>
+            <a:r>
+              <a:rPr lang="en-US" sz="2600" b="1" dirty="0">
+                <a:solidFill>
+                  <a:srgbClr val="FFFFFF"/>
+                </a:solidFill>
+                <a:latin typeface="Calibri" pitchFamily="34" charset="0"/>
+                <a:ea typeface="Calibri" pitchFamily="34" charset="-122"/>
+                <a:cs typeface="Calibri" pitchFamily="34" charset="-120"/>
+              </a:rPr>
+              <a:t> de </a:t>
+            </a:r>
+            <a:r>
+              <a:rPr lang="en-US" sz="2600" b="1" u="sng" dirty="0">
+                <a:solidFill>
+                  <a:srgbClr val="FFFFFF"/>
+                </a:solidFill>
+                <a:latin typeface="Calibri" pitchFamily="34" charset="0"/>
+                <a:ea typeface="Calibri" pitchFamily="34" charset="-122"/>
+                <a:cs typeface="Calibri" pitchFamily="34" charset="-120"/>
+              </a:rPr>
+              <a:t>R Studio</a:t>
+            </a:r>
+            <a:r>
+              <a:rPr lang="en-US" sz="2600" b="1" dirty="0">
+                <a:solidFill>
+                  <a:srgbClr val="FFFFFF"/>
+                </a:solidFill>
+                <a:latin typeface="Calibri" pitchFamily="34" charset="0"/>
+                <a:ea typeface="Calibri" pitchFamily="34" charset="-122"/>
+                <a:cs typeface="Calibri" pitchFamily="34" charset="-120"/>
+              </a:rPr>
+              <a:t> (1/3)</a:t>
             </a:r>
             <a:endParaRPr lang="en-US" sz="2600" dirty="0"/>
           </a:p>
@@ -10368,7 +10706,7 @@
         </p:nvSpPr>
         <p:spPr>
           <a:xfrm>
-            <a:off x="457200" y="603504"/>
+            <a:off x="457200" y="562726"/>
             <a:ext cx="8229600" cy="228600"/>
           </a:xfrm>
           <a:prstGeom prst="rect">
@@ -10393,7 +10731,7 @@
                 <a:ea typeface="Consolas" pitchFamily="34" charset="-122"/>
                 <a:cs typeface="Consolas" pitchFamily="34" charset="-120"/>
               </a:rPr>
-              <a:t>Regresión Lineal  ·  Mapa Coroplético Andalucía</a:t>
+              <a:t>Correlación lineal (Pearson) · dataset codificado numéricamente</a:t>
             </a:r>
             <a:endParaRPr lang="en-US" sz="1000" dirty="0"/>
           </a:p>
@@ -10408,15 +10746,15 @@
           <p:nvPr/>
         </p:nvPicPr>
         <p:blipFill>
-          <a:blip r:embed="rId2"/>
+          <a:blip r:embed="rId3"/>
           <a:stretch>
             <a:fillRect/>
           </a:stretch>
         </p:blipFill>
         <p:spPr>
           <a:xfrm>
-            <a:off x="96336" y="1175004"/>
-            <a:ext cx="4535424" cy="3310128"/>
+            <a:off x="1451819" y="982104"/>
+            <a:ext cx="6788377" cy="3940928"/>
           </a:xfrm>
           <a:prstGeom prst="rect">
             <a:avLst/>
@@ -10431,7 +10769,7 @@
         </p:nvSpPr>
         <p:spPr>
           <a:xfrm>
-            <a:off x="457200" y="4828032"/>
+            <a:off x="457200" y="4928616"/>
             <a:ext cx="7772400" cy="201168"/>
           </a:xfrm>
           <a:prstGeom prst="rect">
@@ -10498,8 +10836,8 @@
         </p:nvSpPr>
         <p:spPr>
           <a:xfrm>
-            <a:off x="274320" y="770400"/>
-            <a:ext cx="4389120" cy="190500"/>
+            <a:off x="274680" y="786436"/>
+            <a:ext cx="8594640" cy="182880"/>
           </a:xfrm>
           <a:prstGeom prst="rect">
             <a:avLst/>
@@ -10521,131 +10859,43 @@
                 </a:solidFill>
                 <a:latin typeface="Calibri" pitchFamily="34" charset="0"/>
               </a:rPr>
-              <a:t>Regresión Lineal: tamaño_habitacion vs precio</a:t>
-            </a:r>
-          </a:p>
-        </p:txBody>
-      </p:sp>
-      <p:sp>
-        <p:nvSpPr>
-          <p:cNvPr id="51" name="LabelArbol"/>
-          <p:cNvSpPr/>
-          <p:nvPr/>
-        </p:nvSpPr>
-        <p:spPr>
-          <a:xfrm>
-            <a:off x="4731120" y="770400"/>
-            <a:ext cx="4130640" cy="190500"/>
-          </a:xfrm>
-          <a:prstGeom prst="rect">
-            <a:avLst/>
-          </a:prstGeom>
-          <a:noFill/>
-          <a:ln/>
-        </p:spPr>
-        <p:txBody>
-          <a:bodyPr wrap="square" lIns="0" tIns="0" rIns="0" bIns="0" rtlCol="0" anchor="ctr"/>
-          <a:lstStyle/>
-          <a:p>
-            <a:pPr marL="0" indent="0">
-              <a:buNone/>
-            </a:pPr>
+              <a:t>📊  Pearson · </a:t>
+            </a:r>
             <a:r>
               <a:rPr lang="es-ES" sz="900" b="1" dirty="0">
                 <a:solidFill>
+                  <a:srgbClr val="FF0000"/>
+                </a:solidFill>
+                <a:latin typeface="Calibri" pitchFamily="34" charset="0"/>
+              </a:rPr>
+              <a:t>R Studio </a:t>
+            </a:r>
+            <a:r>
+              <a:rPr lang="es-ES" sz="900" b="1" dirty="0" err="1">
+                <a:solidFill>
+                  <a:srgbClr val="FF0000"/>
+                </a:solidFill>
+                <a:latin typeface="Calibri" pitchFamily="34" charset="0"/>
+              </a:rPr>
+              <a:t>corrplot</a:t>
+            </a:r>
+            <a:r>
+              <a:rPr lang="es-ES" sz="900" b="1" dirty="0">
+                <a:solidFill>
+                  <a:srgbClr val="FF0000"/>
+                </a:solidFill>
+                <a:latin typeface="Calibri" pitchFamily="34" charset="0"/>
+              </a:rPr>
+              <a:t> </a:t>
+            </a:r>
+            <a:r>
+              <a:rPr lang="es-ES" sz="900" b="1" dirty="0">
+                <a:solidFill>
                   <a:srgbClr val="D4A843"/>
                 </a:solidFill>
                 <a:latin typeface="Calibri" pitchFamily="34" charset="0"/>
               </a:rPr>
-              <a:t>🗺️  Mapa Coroplético Andalucía  ·  plotly.express</a:t>
-            </a:r>
-          </a:p>
-        </p:txBody>
-      </p:sp>
-      <p:sp>
-        <p:nvSpPr>
-          <p:cNvPr id="60" name="MapaDesc"/>
-          <p:cNvSpPr/>
-          <p:nvPr/>
-        </p:nvSpPr>
-        <p:spPr>
-          <a:xfrm>
-            <a:off x="4731120" y="960120"/>
-            <a:ext cx="4130640" cy="1143000"/>
-          </a:xfrm>
-          <a:prstGeom prst="rect">
-            <a:avLst/>
-          </a:prstGeom>
-          <a:solidFill>
-            <a:srgbClr val="1E3A5F"/>
-          </a:solidFill>
-          <a:ln/>
-        </p:spPr>
-        <p:txBody>
-          <a:bodyPr wrap="square" lIns="91440" tIns="91440" rIns="91440" bIns="91440" rtlCol="0" anchor="t"/>
-          <a:lstStyle/>
-          <a:p>
-            <a:pPr marL="0" indent="0">
-              <a:buNone/>
-            </a:pPr>
-            <a:r>
-              <a:rPr lang="es-ES" sz="900" dirty="0">
-                <a:solidFill>
-                  <a:srgbClr val="F4F8FC"/>
-                </a:solidFill>
-                <a:latin typeface="Calibri" pitchFamily="34" charset="0"/>
-              </a:rPr>
-              <a:t>Choropleth por provincias andaluzas (GeoJSON spain-provinces) + scatter de alojamientos únicos (lat/lon). El HTML resultante se usa como mapa por defecto en la app Streamlit del usuario final.</a:t>
-            </a:r>
-          </a:p>
-        </p:txBody>
-      </p:sp>
-      <p:sp>
-        <p:nvSpPr>
-          <p:cNvPr id="61" name="MapaCode"/>
-          <p:cNvSpPr/>
-          <p:nvPr/>
-        </p:nvSpPr>
-        <p:spPr>
-          <a:xfrm>
-            <a:off x="4731120" y="2160120"/>
-            <a:ext cx="4130640" cy="1761876"/>
-          </a:xfrm>
-          <a:prstGeom prst="rect">
-            <a:avLst/>
-          </a:prstGeom>
-          <a:solidFill>
-            <a:srgbClr val="0D1117"/>
-          </a:solidFill>
-          <a:ln/>
-        </p:spPr>
-        <p:txBody>
-          <a:bodyPr wrap="square" lIns="91440" tIns="91440" rIns="91440" bIns="91440" rtlCol="0" anchor="t"/>
-          <a:lstStyle/>
-          <a:p>
-            <a:pPr marL="0" indent="0">
-              <a:buNone/>
-            </a:pPr>
-            <a:r>
-              <a:rPr lang="en-US" sz="800" dirty="0">
-                <a:solidFill>
-                  <a:srgbClr val="E2E8F0"/>
-                </a:solidFill>
-                <a:latin typeface="Consolas" pitchFamily="49" charset="0"/>
-              </a:rPr>
-              <a:t># Mapa coroplético + scatter
-fig = px.choropleth(
-  locations=NOMBRES_PROVINCIAS,
-  geojson=geojson,
-  featureidkey="properties.name",
-  color=alojamientos_por_provincia,
-  color_continuous_scale="Reds")
-fig.add_scattergeo(
-  lat=df['latitud'],
-  lon=df['longitud'],
-  mode="markers",
-  marker=dict(size=5,color="green"))
-fig.write_html(salida)  # → Streamlit</a:t>
+              <a:t>· 30 variables · LabelEncoder + get_dummies</a:t>
             </a:r>
           </a:p>
         </p:txBody>
@@ -10736,29 +10986,7 @@
                 <a:ea typeface="Calibri" pitchFamily="34" charset="-122"/>
                 <a:cs typeface="Calibri" pitchFamily="34" charset="-120"/>
               </a:rPr>
-              <a:t>Visualización · Árbol de </a:t>
-            </a:r>
-            <a:r>
-              <a:rPr lang="en-US" sz="2600" b="1" dirty="0" err="1">
-                <a:solidFill>
-                  <a:srgbClr val="FFFFFF"/>
-                </a:solidFill>
-                <a:latin typeface="Calibri" pitchFamily="34" charset="0"/>
-                <a:ea typeface="Calibri" pitchFamily="34" charset="-122"/>
-                <a:cs typeface="Calibri" pitchFamily="34" charset="-120"/>
-              </a:rPr>
-              <a:t>Decisión</a:t>
-            </a:r>
-            <a:r>
-              <a:rPr lang="en-US" sz="2600" b="1" dirty="0">
-                <a:solidFill>
-                  <a:srgbClr val="FFFFFF"/>
-                </a:solidFill>
-                <a:latin typeface="Calibri" pitchFamily="34" charset="0"/>
-                <a:ea typeface="Calibri" pitchFamily="34" charset="-122"/>
-                <a:cs typeface="Calibri" pitchFamily="34" charset="-120"/>
-              </a:rPr>
-              <a:t> (3/3)</a:t>
+              <a:t>Visualización de Datos  (2/3)</a:t>
             </a:r>
             <a:endParaRPr lang="en-US" sz="2600" dirty="0"/>
           </a:p>
@@ -10797,7 +11025,7 @@
                 <a:ea typeface="Consolas" pitchFamily="34" charset="-122"/>
                 <a:cs typeface="Consolas" pitchFamily="34" charset="-120"/>
               </a:rPr>
-              <a:t>sklearn plot_tree · variable raíz: tamaño_habitacion ≤ 75.5 · primeros 4 niveles</a:t>
+              <a:t>Regresión Lineal  ·  Mapa Coroplético Andalucía</a:t>
             </a:r>
             <a:endParaRPr lang="en-US" sz="1000" dirty="0"/>
           </a:p>
@@ -10805,7 +11033,7 @@
       </p:sp>
       <p:pic>
         <p:nvPicPr>
-          <p:cNvPr id="60" name="ArbolDecision" descr="arbol_decision.png"/>
+          <p:cNvPr id="10" name="Image 0" descr="preencoded.png"/>
           <p:cNvPicPr>
             <a:picLocks noChangeAspect="1"/>
           </p:cNvPicPr>
@@ -10819,8 +11047,24 @@
         </p:blipFill>
         <p:spPr>
           <a:xfrm>
-            <a:off x="274320" y="960120"/>
-            <a:ext cx="8594640" cy="4014720"/>
+            <a:off x="96336" y="1175004"/>
+            <a:ext cx="4535424" cy="3310128"/>
+          </a:xfrm>
+          <a:prstGeom prst="rect">
+            <a:avLst/>
+          </a:prstGeom>
+        </p:spPr>
+      </p:pic>
+      <p:sp>
+        <p:nvSpPr>
+          <p:cNvPr id="33" name="Text 30"/>
+          <p:cNvSpPr/>
+          <p:nvPr/>
+        </p:nvSpPr>
+        <p:spPr>
+          <a:xfrm>
+            <a:off x="457200" y="4828032"/>
+            <a:ext cx="7772400" cy="201168"/>
           </a:xfrm>
           <a:prstGeom prst="rect">
             <a:avLst/>
@@ -10828,7 +11072,216 @@
           <a:noFill/>
           <a:ln/>
         </p:spPr>
-      </p:pic>
+        <p:txBody>
+          <a:bodyPr wrap="square" lIns="0" tIns="0" rIns="0" bIns="0" rtlCol="0" anchor="ctr"/>
+          <a:lstStyle/>
+          <a:p>
+            <a:pPr marL="0" indent="0" algn="l">
+              <a:buNone/>
+            </a:pPr>
+            <a:r>
+              <a:rPr lang="en-US" sz="800" dirty="0">
+                <a:solidFill>
+                  <a:srgbClr val="4A6080"/>
+                </a:solidFill>
+                <a:latin typeface="Calibri" pitchFamily="34" charset="0"/>
+                <a:ea typeface="Calibri" pitchFamily="34" charset="-122"/>
+                <a:cs typeface="Calibri" pitchFamily="34" charset="-120"/>
+              </a:rPr>
+              <a:t>TFG · Detector de Chollos en Andalucía · Mario Jiménez · Universidad de Sevilla</a:t>
+            </a:r>
+            <a:endParaRPr lang="en-US" sz="800" dirty="0"/>
+          </a:p>
+        </p:txBody>
+      </p:sp>
+      <p:sp>
+        <p:nvSpPr>
+          <p:cNvPr id="34" name="Text 31"/>
+          <p:cNvSpPr/>
+          <p:nvPr/>
+        </p:nvSpPr>
+        <p:spPr>
+          <a:xfrm>
+            <a:off x="8595360" y="4754880"/>
+            <a:ext cx="365760" cy="228600"/>
+          </a:xfrm>
+          <a:prstGeom prst="rect">
+            <a:avLst/>
+          </a:prstGeom>
+          <a:noFill/>
+          <a:ln/>
+        </p:spPr>
+        <p:txBody>
+          <a:bodyPr wrap="square" lIns="0" tIns="0" rIns="0" bIns="0" rtlCol="0" anchor="ctr"/>
+          <a:lstStyle/>
+          <a:p>
+            <a:pPr marL="0" indent="0" algn="ctr">
+              <a:buNone/>
+            </a:pPr>
+            <a:endParaRPr lang="en-US" sz="900" dirty="0"/>
+          </a:p>
+        </p:txBody>
+      </p:sp>
+      <p:sp>
+        <p:nvSpPr>
+          <p:cNvPr id="50" name="LabelCorrplot"/>
+          <p:cNvSpPr/>
+          <p:nvPr/>
+        </p:nvSpPr>
+        <p:spPr>
+          <a:xfrm>
+            <a:off x="274320" y="770400"/>
+            <a:ext cx="4389120" cy="190500"/>
+          </a:xfrm>
+          <a:prstGeom prst="rect">
+            <a:avLst/>
+          </a:prstGeom>
+          <a:noFill/>
+          <a:ln/>
+        </p:spPr>
+        <p:txBody>
+          <a:bodyPr wrap="square" lIns="0" tIns="0" rIns="0" bIns="0" rtlCol="0" anchor="ctr"/>
+          <a:lstStyle/>
+          <a:p>
+            <a:pPr marL="0" indent="0">
+              <a:buNone/>
+            </a:pPr>
+            <a:r>
+              <a:rPr lang="es-ES" sz="900" b="1" dirty="0">
+                <a:solidFill>
+                  <a:srgbClr val="D4A843"/>
+                </a:solidFill>
+                <a:latin typeface="Calibri" pitchFamily="34" charset="0"/>
+              </a:rPr>
+              <a:t>Regresión Lineal: tamaño_habitacion vs precio</a:t>
+            </a:r>
+          </a:p>
+        </p:txBody>
+      </p:sp>
+      <p:sp>
+        <p:nvSpPr>
+          <p:cNvPr id="51" name="LabelArbol"/>
+          <p:cNvSpPr/>
+          <p:nvPr/>
+        </p:nvSpPr>
+        <p:spPr>
+          <a:xfrm>
+            <a:off x="4731120" y="770400"/>
+            <a:ext cx="4130640" cy="190500"/>
+          </a:xfrm>
+          <a:prstGeom prst="rect">
+            <a:avLst/>
+          </a:prstGeom>
+          <a:noFill/>
+          <a:ln/>
+        </p:spPr>
+        <p:txBody>
+          <a:bodyPr wrap="square" lIns="0" tIns="0" rIns="0" bIns="0" rtlCol="0" anchor="ctr"/>
+          <a:lstStyle/>
+          <a:p>
+            <a:pPr marL="0" indent="0">
+              <a:buNone/>
+            </a:pPr>
+            <a:r>
+              <a:rPr lang="es-ES" sz="900" b="1" dirty="0">
+                <a:solidFill>
+                  <a:srgbClr val="D4A843"/>
+                </a:solidFill>
+                <a:latin typeface="Calibri" pitchFamily="34" charset="0"/>
+              </a:rPr>
+              <a:t>🗺️  Mapa Coroplético Andalucía  ·  plotly.express</a:t>
+            </a:r>
+          </a:p>
+        </p:txBody>
+      </p:sp>
+      <p:sp>
+        <p:nvSpPr>
+          <p:cNvPr id="60" name="MapaDesc"/>
+          <p:cNvSpPr/>
+          <p:nvPr/>
+        </p:nvSpPr>
+        <p:spPr>
+          <a:xfrm>
+            <a:off x="4731120" y="960120"/>
+            <a:ext cx="4130640" cy="1143000"/>
+          </a:xfrm>
+          <a:prstGeom prst="rect">
+            <a:avLst/>
+          </a:prstGeom>
+          <a:solidFill>
+            <a:srgbClr val="1E3A5F"/>
+          </a:solidFill>
+          <a:ln/>
+        </p:spPr>
+        <p:txBody>
+          <a:bodyPr wrap="square" lIns="91440" tIns="91440" rIns="91440" bIns="91440" rtlCol="0" anchor="t"/>
+          <a:lstStyle/>
+          <a:p>
+            <a:pPr marL="0" indent="0">
+              <a:buNone/>
+            </a:pPr>
+            <a:r>
+              <a:rPr lang="es-ES" sz="900" dirty="0">
+                <a:solidFill>
+                  <a:srgbClr val="F4F8FC"/>
+                </a:solidFill>
+                <a:latin typeface="Calibri" pitchFamily="34" charset="0"/>
+              </a:rPr>
+              <a:t>Choropleth por provincias andaluzas (GeoJSON spain-provinces) + scatter de alojamientos únicos (lat/lon). El HTML resultante se usa como mapa por defecto en la app Streamlit del usuario final.</a:t>
+            </a:r>
+          </a:p>
+        </p:txBody>
+      </p:sp>
+      <p:sp>
+        <p:nvSpPr>
+          <p:cNvPr id="61" name="MapaCode"/>
+          <p:cNvSpPr/>
+          <p:nvPr/>
+        </p:nvSpPr>
+        <p:spPr>
+          <a:xfrm>
+            <a:off x="4731120" y="2160120"/>
+            <a:ext cx="4130640" cy="1761876"/>
+          </a:xfrm>
+          <a:prstGeom prst="rect">
+            <a:avLst/>
+          </a:prstGeom>
+          <a:solidFill>
+            <a:srgbClr val="0D1117"/>
+          </a:solidFill>
+          <a:ln/>
+        </p:spPr>
+        <p:txBody>
+          <a:bodyPr wrap="square" lIns="91440" tIns="91440" rIns="91440" bIns="91440" rtlCol="0" anchor="t"/>
+          <a:lstStyle/>
+          <a:p>
+            <a:pPr marL="0" indent="0">
+              <a:buNone/>
+            </a:pPr>
+            <a:r>
+              <a:rPr lang="en-US" sz="800" dirty="0">
+                <a:solidFill>
+                  <a:srgbClr val="E2E8F0"/>
+                </a:solidFill>
+                <a:latin typeface="Consolas" pitchFamily="49" charset="0"/>
+              </a:rPr>
+              <a:t># Mapa coroplético + scatter
+fig = px.choropleth(
+  locations=NOMBRES_PROVINCIAS,
+  geojson=geojson,
+  featureidkey="properties.name",
+  color=alojamientos_por_provincia,
+  color_continuous_scale="Reds")
+fig.add_scattergeo(
+  lat=df['latitud'],
+  lon=df['longitud'],
+  mode="markers",
+  marker=dict(size=5,color="green"))
+fig.write_html(salida)  # → Streamlit</a:t>
+            </a:r>
+          </a:p>
+        </p:txBody>
+      </p:sp>
     </p:spTree>
   </p:cSld>
   <p:clrMapOvr>
@@ -10839,7 +11292,7 @@
 
 <file path=ppt/slides/slide19.xml><?xml version="1.0" encoding="utf-8"?>
 <p:sld xmlns:a="http://schemas.openxmlformats.org/drawingml/2006/main" xmlns:r="http://schemas.openxmlformats.org/officeDocument/2006/relationships" xmlns:p="http://schemas.openxmlformats.org/presentationml/2006/main">
-  <p:cSld>
+  <p:cSld name="Slide 9">
     <p:bg>
       <p:bgPr>
         <a:solidFill>
@@ -10864,7 +11317,7 @@
       </p:grpSpPr>
       <p:sp>
         <p:nvSpPr>
-          <p:cNvPr id="2" name="Gold"/>
+          <p:cNvPr id="2" name="Shape 0"/>
           <p:cNvSpPr/>
           <p:nvPr/>
         </p:nvSpPr>
@@ -10884,13 +11337,13 @@
       </p:sp>
       <p:sp>
         <p:nvSpPr>
-          <p:cNvPr id="3" name="Title"/>
-          <p:cNvSpPr/>
-          <p:nvPr/>
-        </p:nvSpPr>
-        <p:spPr>
-          <a:xfrm>
-            <a:off x="457200" y="109728"/>
+          <p:cNvPr id="3" name="Text 1"/>
+          <p:cNvSpPr/>
+          <p:nvPr/>
+        </p:nvSpPr>
+        <p:spPr>
+          <a:xfrm>
+            <a:off x="457200" y="146304"/>
             <a:ext cx="8229600" cy="457200"/>
           </a:xfrm>
           <a:prstGeom prst="rect">
@@ -10907,20 +11360,45 @@
               <a:buNone/>
             </a:pPr>
             <a:r>
-              <a:rPr lang="es-ES" sz="2400" b="1" dirty="0">
+              <a:rPr lang="en-US" sz="2600" b="1" dirty="0">
                 <a:solidFill>
                   <a:srgbClr val="FFFFFF"/>
                 </a:solidFill>
                 <a:latin typeface="Calibri" pitchFamily="34" charset="0"/>
-              </a:rPr>
-              <a:t>Resultados de los Modelos · Conjunto de TEST</a:t>
-            </a:r>
-          </a:p>
-        </p:txBody>
-      </p:sp>
-      <p:sp>
-        <p:nvSpPr>
-          <p:cNvPr id="4" name="Sub"/>
+                <a:ea typeface="Calibri" pitchFamily="34" charset="-122"/>
+                <a:cs typeface="Calibri" pitchFamily="34" charset="-120"/>
+              </a:rPr>
+              <a:t>Visualización · Árbol de </a:t>
+            </a:r>
+            <a:r>
+              <a:rPr lang="en-US" sz="2600" b="1" dirty="0" err="1">
+                <a:solidFill>
+                  <a:srgbClr val="FFFFFF"/>
+                </a:solidFill>
+                <a:latin typeface="Calibri" pitchFamily="34" charset="0"/>
+                <a:ea typeface="Calibri" pitchFamily="34" charset="-122"/>
+                <a:cs typeface="Calibri" pitchFamily="34" charset="-120"/>
+              </a:rPr>
+              <a:t>Decisión</a:t>
+            </a:r>
+            <a:r>
+              <a:rPr lang="en-US" sz="2600" b="1" dirty="0">
+                <a:solidFill>
+                  <a:srgbClr val="FFFFFF"/>
+                </a:solidFill>
+                <a:latin typeface="Calibri" pitchFamily="34" charset="0"/>
+                <a:ea typeface="Calibri" pitchFamily="34" charset="-122"/>
+                <a:cs typeface="Calibri" pitchFamily="34" charset="-120"/>
+              </a:rPr>
+              <a:t> (3/3)</a:t>
+            </a:r>
+            <a:endParaRPr lang="en-US" sz="2600" dirty="0"/>
+          </a:p>
+        </p:txBody>
+      </p:sp>
+      <p:sp>
+        <p:nvSpPr>
+          <p:cNvPr id="4" name="Text 2"/>
           <p:cNvSpPr/>
           <p:nvPr/>
         </p:nvSpPr>
@@ -10943,58 +11421,23 @@
               <a:buNone/>
             </a:pPr>
             <a:r>
-              <a:rPr lang="es-ES" sz="1000" dirty="0">
+              <a:rPr lang="en-US" sz="1000" dirty="0">
                 <a:solidFill>
                   <a:srgbClr val="F0C060"/>
                 </a:solidFill>
                 <a:latin typeface="Consolas" pitchFamily="34" charset="0"/>
-              </a:rPr>
-              <a:t>Modelizacion/Modelizacion.py · Evaluación final (X_test, usado una única vez)</a:t>
-            </a:r>
-          </a:p>
-        </p:txBody>
-      </p:sp>
-      <p:sp>
-        <p:nvSpPr>
-          <p:cNvPr id="5" name="LblTabla"/>
-          <p:cNvSpPr/>
-          <p:nvPr/>
-        </p:nvSpPr>
-        <p:spPr>
-          <a:xfrm>
-            <a:off x="182880" y="868680"/>
-            <a:ext cx="5486400" cy="228600"/>
-          </a:xfrm>
-          <a:prstGeom prst="rect">
-            <a:avLst/>
-          </a:prstGeom>
-          <a:solidFill>
-            <a:srgbClr val="2A5080"/>
-          </a:solidFill>
-          <a:ln/>
-        </p:spPr>
-        <p:txBody>
-          <a:bodyPr wrap="square" lIns="91440" tIns="45720" rIns="91440" bIns="45720" rtlCol="0" anchor="ctr"/>
-          <a:lstStyle/>
-          <a:p>
-            <a:pPr marL="0" indent="0">
-              <a:buNone/>
-            </a:pPr>
-            <a:r>
-              <a:rPr lang="es-ES" sz="950" b="1" dirty="0">
-                <a:solidFill>
-                  <a:srgbClr val="D4A843"/>
-                </a:solidFill>
-                <a:latin typeface="Calibri" pitchFamily="34" charset="0"/>
-              </a:rPr>
-              <a:t>📊  Comparativa de modelos — Métricas sobre conjunto de TEST</a:t>
-            </a:r>
+                <a:ea typeface="Consolas" pitchFamily="34" charset="-122"/>
+                <a:cs typeface="Consolas" pitchFamily="34" charset="-120"/>
+              </a:rPr>
+              <a:t>sklearn plot_tree · variable raíz: tamaño_habitacion ≤ 75.5 · primeros 4 niveles</a:t>
+            </a:r>
+            <a:endParaRPr lang="en-US" sz="1000" dirty="0"/>
           </a:p>
         </p:txBody>
       </p:sp>
       <p:pic>
         <p:nvPicPr>
-          <p:cNvPr id="6" name="TablaMetricas"/>
+          <p:cNvPr id="60" name="ArbolDecision" descr="arbol_decision.png"/>
           <p:cNvPicPr>
             <a:picLocks noChangeAspect="1"/>
           </p:cNvPicPr>
@@ -11008,8 +11451,8 @@
         </p:blipFill>
         <p:spPr>
           <a:xfrm>
-            <a:off x="182880" y="1097280"/>
-            <a:ext cx="5486400" cy="1554480"/>
+            <a:off x="274320" y="960120"/>
+            <a:ext cx="8594640" cy="4014720"/>
           </a:xfrm>
           <a:prstGeom prst="rect">
             <a:avLst/>
@@ -11018,475 +11461,6 @@
           <a:ln/>
         </p:spPr>
       </p:pic>
-      <p:sp>
-        <p:nvSpPr>
-          <p:cNvPr id="7" name="WinnerBox"/>
-          <p:cNvSpPr/>
-          <p:nvPr/>
-        </p:nvSpPr>
-        <p:spPr>
-          <a:xfrm>
-            <a:off x="5852880" y="868680"/>
-            <a:ext cx="3108960" cy="1783080"/>
-          </a:xfrm>
-          <a:prstGeom prst="rect">
-            <a:avLst/>
-          </a:prstGeom>
-          <a:solidFill>
-            <a:srgbClr val="1E3A5F"/>
-          </a:solidFill>
-          <a:ln>
-            <a:solidFill>
-              <a:srgbClr val="16A34A"/>
-            </a:solidFill>
-          </a:ln>
-        </p:spPr>
-        <p:txBody>
-          <a:bodyPr wrap="square" lIns="182880" tIns="91440" rIns="182880" bIns="91440" rtlCol="0" anchor="ctr"/>
-          <a:lstStyle/>
-          <a:p>
-            <a:pPr marL="0" indent="0">
-              <a:buNone/>
-            </a:pPr>
-            <a:r>
-              <a:rPr lang="es-ES" sz="1050" b="1" dirty="0">
-                <a:solidFill>
-                  <a:srgbClr val="16A34A"/>
-                </a:solidFill>
-                <a:latin typeface="Calibri" pitchFamily="34" charset="0"/>
-              </a:rPr>
-              <a:t>🏆  Mejor modelo: Bosque Aleatorio</a:t>
-            </a:r>
-          </a:p>
-          <a:p>
-            <a:pPr marL="0" indent="0">
-              <a:buNone/>
-            </a:pPr>
-            <a:r>
-              <a:rPr lang="es-ES" sz="800" dirty="0">
-                <a:latin typeface="Calibri" pitchFamily="34" charset="0"/>
-              </a:rPr>
-              <a:t> </a:t>
-            </a:r>
-          </a:p>
-          <a:p>
-            <a:pPr marL="0" indent="0">
-              <a:buNone/>
-            </a:pPr>
-            <a:r>
-              <a:rPr lang="es-ES" sz="1000" b="1" dirty="0">
-                <a:solidFill>
-                  <a:srgbClr val="D4A843"/>
-                </a:solidFill>
-                <a:latin typeface="Calibri" pitchFamily="34" charset="0"/>
-              </a:rPr>
-              <a:t>R²</a:t>
-            </a:r>
-            <a:r>
-              <a:rPr lang="es-ES" sz="900" dirty="0">
-                <a:solidFill>
-                  <a:srgbClr val="CBD5E1"/>
-                </a:solidFill>
-                <a:latin typeface="Calibri" pitchFamily="34" charset="0"/>
-              </a:rPr>
-              <a:t>  =  </a:t>
-            </a:r>
-            <a:r>
-              <a:rPr lang="es-ES" sz="2200" b="1" dirty="0">
-                <a:solidFill>
-                  <a:srgbClr val="FFFFFF"/>
-                </a:solidFill>
-                <a:latin typeface="Calibri" pitchFamily="34" charset="0"/>
-              </a:rPr>
-              <a:t>0.8779</a:t>
-            </a:r>
-          </a:p>
-          <a:p>
-            <a:pPr marL="0" indent="0">
-              <a:buNone/>
-            </a:pPr>
-            <a:r>
-              <a:rPr lang="es-ES" sz="1000" b="1" dirty="0">
-                <a:solidFill>
-                  <a:srgbClr val="D4A843"/>
-                </a:solidFill>
-                <a:latin typeface="Calibri" pitchFamily="34" charset="0"/>
-              </a:rPr>
-              <a:t>MAE</a:t>
-            </a:r>
-            <a:r>
-              <a:rPr lang="es-ES" sz="900" dirty="0">
-                <a:solidFill>
-                  <a:srgbClr val="CBD5E1"/>
-                </a:solidFill>
-                <a:latin typeface="Calibri" pitchFamily="34" charset="0"/>
-              </a:rPr>
-              <a:t>  =  </a:t>
-            </a:r>
-            <a:r>
-              <a:rPr lang="es-ES" sz="1800" b="1" dirty="0">
-                <a:solidFill>
-                  <a:srgbClr val="F4F8FC"/>
-                </a:solidFill>
-                <a:latin typeface="Calibri" pitchFamily="34" charset="0"/>
-              </a:rPr>
-              <a:t>19.45 €</a:t>
-            </a:r>
-          </a:p>
-          <a:p>
-            <a:pPr marL="0" indent="0">
-              <a:buNone/>
-            </a:pPr>
-            <a:r>
-              <a:rPr lang="es-ES" sz="1000" b="1" dirty="0">
-                <a:solidFill>
-                  <a:srgbClr val="D4A843"/>
-                </a:solidFill>
-                <a:latin typeface="Calibri" pitchFamily="34" charset="0"/>
-              </a:rPr>
-              <a:t>RMSE</a:t>
-            </a:r>
-            <a:r>
-              <a:rPr lang="es-ES" sz="900" dirty="0">
-                <a:solidFill>
-                  <a:srgbClr val="CBD5E1"/>
-                </a:solidFill>
-                <a:latin typeface="Calibri" pitchFamily="34" charset="0"/>
-              </a:rPr>
-              <a:t>  =  </a:t>
-            </a:r>
-            <a:r>
-              <a:rPr lang="es-ES" sz="1800" b="1" dirty="0">
-                <a:solidFill>
-                  <a:srgbClr val="F4F8FC"/>
-                </a:solidFill>
-                <a:latin typeface="Calibri" pitchFamily="34" charset="0"/>
-              </a:rPr>
-              <a:t>33.18 €</a:t>
-            </a:r>
-          </a:p>
-          <a:p>
-            <a:pPr marL="0" indent="0">
-              <a:buNone/>
-            </a:pPr>
-            <a:r>
-              <a:rPr lang="es-ES" sz="800" dirty="0">
-                <a:latin typeface="Calibri" pitchFamily="34" charset="0"/>
-              </a:rPr>
-              <a:t> </a:t>
-            </a:r>
-          </a:p>
-          <a:p>
-            <a:pPr marL="0" indent="0">
-              <a:buNone/>
-            </a:pPr>
-            <a:r>
-              <a:rPr lang="es-ES" sz="900" dirty="0">
-                <a:solidFill>
-                  <a:srgbClr val="CBD5E1"/>
-                </a:solidFill>
-                <a:latin typeface="Calibri" pitchFamily="34" charset="0"/>
-              </a:rPr>
-              <a:t>Explica el 87,8% de la varianza del precio.
-Error medio de ±19,45€ sobre el precio real.</a:t>
-            </a:r>
-          </a:p>
-        </p:txBody>
-      </p:sp>
-      <p:sp>
-        <p:nvSpPr>
-          <p:cNvPr id="8" name="LblDist"/>
-          <p:cNvSpPr/>
-          <p:nvPr/>
-        </p:nvSpPr>
-        <p:spPr>
-          <a:xfrm>
-            <a:off x="182880" y="2743200"/>
-            <a:ext cx="4921383" cy="228600"/>
-          </a:xfrm>
-          <a:prstGeom prst="rect">
-            <a:avLst/>
-          </a:prstGeom>
-          <a:solidFill>
-            <a:srgbClr val="1F5C40"/>
-          </a:solidFill>
-          <a:ln/>
-        </p:spPr>
-        <p:txBody>
-          <a:bodyPr wrap="square" lIns="91440" tIns="45720" rIns="91440" bIns="45720" rtlCol="0" anchor="ctr"/>
-          <a:lstStyle/>
-          <a:p>
-            <a:pPr marL="0" indent="0">
-              <a:buNone/>
-            </a:pPr>
-            <a:r>
-              <a:rPr lang="es-ES" sz="950" b="1" dirty="0">
-                <a:solidFill>
-                  <a:srgbClr val="D4A843"/>
-                </a:solidFill>
-                <a:latin typeface="Calibri" pitchFamily="34" charset="0"/>
-              </a:rPr>
-              <a:t>📊  Distribución de categorías de chollo — Conjunto TEST (414.936 registros)</a:t>
-            </a:r>
-          </a:p>
-        </p:txBody>
-      </p:sp>
-      <p:pic>
-        <p:nvPicPr>
-          <p:cNvPr id="9" name="TablaDistrib"/>
-          <p:cNvPicPr>
-            <a:picLocks noChangeAspect="1"/>
-          </p:cNvPicPr>
-          <p:nvPr/>
-        </p:nvPicPr>
-        <p:blipFill>
-          <a:blip r:embed="rId3"/>
-          <a:stretch>
-            <a:fillRect/>
-          </a:stretch>
-        </p:blipFill>
-        <p:spPr>
-          <a:xfrm>
-            <a:off x="182880" y="2972880"/>
-            <a:ext cx="4921383" cy="1782000"/>
-          </a:xfrm>
-          <a:prstGeom prst="rect">
-            <a:avLst/>
-          </a:prstGeom>
-          <a:noFill/>
-          <a:ln/>
-        </p:spPr>
-      </p:pic>
-      <p:sp>
-        <p:nvSpPr>
-          <p:cNvPr id="10" name="InsightBox"/>
-          <p:cNvSpPr/>
-          <p:nvPr/>
-        </p:nvSpPr>
-        <p:spPr>
-          <a:xfrm>
-            <a:off x="5424985" y="2743200"/>
-            <a:ext cx="3536855" cy="2011680"/>
-          </a:xfrm>
-          <a:prstGeom prst="rect">
-            <a:avLst/>
-          </a:prstGeom>
-          <a:solidFill>
-            <a:srgbClr val="1E3A5F"/>
-          </a:solidFill>
-          <a:ln>
-            <a:solidFill>
-              <a:srgbClr val="2A5080"/>
-            </a:solidFill>
-          </a:ln>
-        </p:spPr>
-        <p:txBody>
-          <a:bodyPr wrap="square" lIns="182880" tIns="182880" rIns="182880" bIns="91440" rtlCol="0" anchor="t"/>
-          <a:lstStyle/>
-          <a:p>
-            <a:pPr marL="0" indent="0">
-              <a:buNone/>
-            </a:pPr>
-            <a:r>
-              <a:rPr lang="es-ES" sz="1000" b="1" dirty="0">
-                <a:solidFill>
-                  <a:srgbClr val="D4A843"/>
-                </a:solidFill>
-                <a:latin typeface="Calibri" pitchFamily="34" charset="0"/>
-              </a:rPr>
-              <a:t>💡  Interpretación:</a:t>
-            </a:r>
-          </a:p>
-          <a:p>
-            <a:pPr marL="0" indent="0">
-              <a:buNone/>
-            </a:pPr>
-            <a:r>
-              <a:rPr lang="es-ES" sz="800" dirty="0">
-                <a:latin typeface="Calibri" pitchFamily="34" charset="0"/>
-              </a:rPr>
-              <a:t> </a:t>
-            </a:r>
-          </a:p>
-          <a:p>
-            <a:pPr marL="0" indent="0">
-              <a:buNone/>
-            </a:pPr>
-            <a:r>
-              <a:rPr lang="es-ES" sz="900" b="1" dirty="0">
-                <a:solidFill>
-                  <a:srgbClr val="16A34A"/>
-                </a:solidFill>
-                <a:latin typeface="Calibri" pitchFamily="34" charset="0"/>
-              </a:rPr>
-              <a:t>Chollos detectados</a:t>
-            </a:r>
-          </a:p>
-          <a:p>
-            <a:pPr marL="0" indent="0">
-              <a:buNone/>
-            </a:pPr>
-            <a:r>
-              <a:rPr lang="es-ES" sz="850" dirty="0">
-                <a:solidFill>
-                  <a:srgbClr val="CBD5E1"/>
-                </a:solidFill>
-                <a:latin typeface="Calibri" pitchFamily="34" charset="0"/>
-              </a:rPr>
-              <a:t>chollo + super + híper-chollo</a:t>
-            </a:r>
-          </a:p>
-          <a:p>
-            <a:pPr marL="0" indent="0">
-              <a:buNone/>
-            </a:pPr>
-            <a:r>
-              <a:rPr lang="es-ES" sz="1300" b="1" dirty="0">
-                <a:solidFill>
-                  <a:srgbClr val="FFFFFF"/>
-                </a:solidFill>
-                <a:latin typeface="Calibri" pitchFamily="34" charset="0"/>
-              </a:rPr>
-              <a:t>= 206.006 registros</a:t>
-            </a:r>
-          </a:p>
-          <a:p>
-            <a:pPr marL="0" indent="0">
-              <a:buNone/>
-            </a:pPr>
-            <a:r>
-              <a:rPr lang="es-ES" sz="1000" b="1" dirty="0">
-                <a:solidFill>
-                  <a:srgbClr val="16A34A"/>
-                </a:solidFill>
-                <a:latin typeface="Calibri" pitchFamily="34" charset="0"/>
-              </a:rPr>
-              <a:t>= 49,9% del conjunto TEST</a:t>
-            </a:r>
-          </a:p>
-          <a:p>
-            <a:pPr marL="0" indent="0">
-              <a:buNone/>
-            </a:pPr>
-            <a:r>
-              <a:rPr lang="es-ES" sz="800" dirty="0">
-                <a:latin typeface="Calibri" pitchFamily="34" charset="0"/>
-              </a:rPr>
-              <a:t> </a:t>
-            </a:r>
-          </a:p>
-          <a:p>
-            <a:pPr marL="0" indent="0">
-              <a:buNone/>
-            </a:pPr>
-            <a:r>
-              <a:rPr lang="es-ES" sz="900" dirty="0">
-                <a:solidFill>
-                  <a:srgbClr val="CBD5E1"/>
-                </a:solidFill>
-                <a:latin typeface="Calibri" pitchFamily="34" charset="0"/>
-              </a:rPr>
-              <a:t>El modelo identifica correctamente
-casi 1 de cada 2 alojamientos
-como oportunidad de ahorro.</a:t>
-            </a:r>
-          </a:p>
-          <a:p>
-            <a:pPr marL="0" indent="0">
-              <a:buNone/>
-            </a:pPr>
-            <a:r>
-              <a:rPr lang="es-ES" sz="800" dirty="0">
-                <a:latin typeface="Calibri" pitchFamily="34" charset="0"/>
-              </a:rPr>
-              <a:t> </a:t>
-            </a:r>
-          </a:p>
-          <a:p>
-            <a:pPr marL="0" indent="0">
-              <a:buNone/>
-            </a:pPr>
-            <a:r>
-              <a:rPr lang="es-ES" sz="850" dirty="0">
-                <a:solidFill>
-                  <a:srgbClr val="8899AA"/>
-                </a:solidFill>
-                <a:latin typeface="Calibri" pitchFamily="34" charset="0"/>
-              </a:rPr>
-              <a:t>Inflado + Normal = 207.930 (50.1%)</a:t>
-            </a:r>
-          </a:p>
-        </p:txBody>
-      </p:sp>
-      <p:sp>
-        <p:nvSpPr>
-          <p:cNvPr id="97" name="Footer"/>
-          <p:cNvSpPr/>
-          <p:nvPr/>
-        </p:nvSpPr>
-        <p:spPr>
-          <a:xfrm>
-            <a:off x="457200" y="4826520"/>
-            <a:ext cx="7772400" cy="200000"/>
-          </a:xfrm>
-          <a:prstGeom prst="rect">
-            <a:avLst/>
-          </a:prstGeom>
-          <a:noFill/>
-          <a:ln/>
-        </p:spPr>
-        <p:txBody>
-          <a:bodyPr wrap="square" lIns="0" tIns="0" rIns="0" bIns="0" rtlCol="0" anchor="ctr"/>
-          <a:lstStyle/>
-          <a:p>
-            <a:pPr marL="0" indent="0">
-              <a:buNone/>
-            </a:pPr>
-            <a:r>
-              <a:rPr lang="es-ES" sz="800" dirty="0">
-                <a:solidFill>
-                  <a:srgbClr val="4A6080"/>
-                </a:solidFill>
-                <a:latin typeface="Calibri" pitchFamily="34" charset="0"/>
-              </a:rPr>
-              <a:t>TFG · Detector de Chollos en Andalucía · Mario Jiménez · Universidad de Sevilla</a:t>
-            </a:r>
-          </a:p>
-        </p:txBody>
-      </p:sp>
-      <p:sp>
-        <p:nvSpPr>
-          <p:cNvPr id="98" name="PageNum"/>
-          <p:cNvSpPr/>
-          <p:nvPr/>
-        </p:nvSpPr>
-        <p:spPr>
-          <a:xfrm>
-            <a:off x="8594640" y="4754880"/>
-            <a:ext cx="365760" cy="228600"/>
-          </a:xfrm>
-          <a:prstGeom prst="rect">
-            <a:avLst/>
-          </a:prstGeom>
-          <a:noFill/>
-          <a:ln/>
-        </p:spPr>
-        <p:txBody>
-          <a:bodyPr wrap="square" lIns="0" tIns="0" rIns="0" bIns="0" rtlCol="0" anchor="ctr"/>
-          <a:lstStyle/>
-          <a:p>
-            <a:pPr marL="0" indent="0">
-              <a:buNone/>
-            </a:pPr>
-            <a:endParaRPr lang="es-ES" sz="900" dirty="0">
-              <a:solidFill>
-                <a:srgbClr val="4A6080"/>
-              </a:solidFill>
-              <a:latin typeface="Calibri" pitchFamily="34" charset="0"/>
-            </a:endParaRPr>
-          </a:p>
-        </p:txBody>
-      </p:sp>
     </p:spTree>
   </p:cSld>
   <p:clrMapOvr>
@@ -13673,6 +13647,664 @@
 
 <file path=ppt/slides/slide20.xml><?xml version="1.0" encoding="utf-8"?>
 <p:sld xmlns:a="http://schemas.openxmlformats.org/drawingml/2006/main" xmlns:r="http://schemas.openxmlformats.org/officeDocument/2006/relationships" xmlns:p="http://schemas.openxmlformats.org/presentationml/2006/main">
+  <p:cSld>
+    <p:bg>
+      <p:bgPr>
+        <a:solidFill>
+          <a:srgbClr val="1A2E4A"/>
+        </a:solidFill>
+        <a:effectLst/>
+      </p:bgPr>
+    </p:bg>
+    <p:spTree>
+      <p:nvGrpSpPr>
+        <p:cNvPr id="1" name=""/>
+        <p:cNvGrpSpPr/>
+        <p:nvPr/>
+      </p:nvGrpSpPr>
+      <p:grpSpPr>
+        <a:xfrm>
+          <a:off x="0" y="0"/>
+          <a:ext cx="0" cy="0"/>
+          <a:chOff x="0" y="0"/>
+          <a:chExt cx="0" cy="0"/>
+        </a:xfrm>
+      </p:grpSpPr>
+      <p:sp>
+        <p:nvSpPr>
+          <p:cNvPr id="2" name="Gold"/>
+          <p:cNvSpPr/>
+          <p:nvPr/>
+        </p:nvSpPr>
+        <p:spPr>
+          <a:xfrm>
+            <a:off x="0" y="0"/>
+            <a:ext cx="9144000" cy="54864"/>
+          </a:xfrm>
+          <a:prstGeom prst="rect">
+            <a:avLst/>
+          </a:prstGeom>
+          <a:solidFill>
+            <a:srgbClr val="D4A843"/>
+          </a:solidFill>
+          <a:ln/>
+        </p:spPr>
+      </p:sp>
+      <p:sp>
+        <p:nvSpPr>
+          <p:cNvPr id="3" name="Title"/>
+          <p:cNvSpPr/>
+          <p:nvPr/>
+        </p:nvSpPr>
+        <p:spPr>
+          <a:xfrm>
+            <a:off x="457200" y="109728"/>
+            <a:ext cx="8229600" cy="457200"/>
+          </a:xfrm>
+          <a:prstGeom prst="rect">
+            <a:avLst/>
+          </a:prstGeom>
+          <a:noFill/>
+          <a:ln/>
+        </p:spPr>
+        <p:txBody>
+          <a:bodyPr wrap="square" lIns="0" tIns="0" rIns="0" bIns="0" rtlCol="0" anchor="ctr"/>
+          <a:lstStyle/>
+          <a:p>
+            <a:pPr marL="0" indent="0">
+              <a:buNone/>
+            </a:pPr>
+            <a:r>
+              <a:rPr lang="es-ES" sz="2400" b="1" dirty="0">
+                <a:solidFill>
+                  <a:srgbClr val="FFFFFF"/>
+                </a:solidFill>
+                <a:latin typeface="Calibri" pitchFamily="34" charset="0"/>
+              </a:rPr>
+              <a:t>Resultados de los Modelos · Conjunto de TEST</a:t>
+            </a:r>
+          </a:p>
+        </p:txBody>
+      </p:sp>
+      <p:sp>
+        <p:nvSpPr>
+          <p:cNvPr id="4" name="Sub"/>
+          <p:cNvSpPr/>
+          <p:nvPr/>
+        </p:nvSpPr>
+        <p:spPr>
+          <a:xfrm>
+            <a:off x="457200" y="603504"/>
+            <a:ext cx="8229600" cy="228600"/>
+          </a:xfrm>
+          <a:prstGeom prst="rect">
+            <a:avLst/>
+          </a:prstGeom>
+          <a:noFill/>
+          <a:ln/>
+        </p:spPr>
+        <p:txBody>
+          <a:bodyPr wrap="square" lIns="0" tIns="0" rIns="0" bIns="0" rtlCol="0" anchor="ctr"/>
+          <a:lstStyle/>
+          <a:p>
+            <a:pPr marL="0" indent="0">
+              <a:buNone/>
+            </a:pPr>
+            <a:r>
+              <a:rPr lang="es-ES" sz="1000" dirty="0">
+                <a:solidFill>
+                  <a:srgbClr val="F0C060"/>
+                </a:solidFill>
+                <a:latin typeface="Consolas" pitchFamily="34" charset="0"/>
+              </a:rPr>
+              <a:t>Modelizacion/Modelizacion.py · Evaluación final (X_test, usado una única vez)</a:t>
+            </a:r>
+          </a:p>
+        </p:txBody>
+      </p:sp>
+      <p:sp>
+        <p:nvSpPr>
+          <p:cNvPr id="5" name="LblTabla"/>
+          <p:cNvSpPr/>
+          <p:nvPr/>
+        </p:nvSpPr>
+        <p:spPr>
+          <a:xfrm>
+            <a:off x="182880" y="868680"/>
+            <a:ext cx="5486400" cy="228600"/>
+          </a:xfrm>
+          <a:prstGeom prst="rect">
+            <a:avLst/>
+          </a:prstGeom>
+          <a:solidFill>
+            <a:srgbClr val="2A5080"/>
+          </a:solidFill>
+          <a:ln/>
+        </p:spPr>
+        <p:txBody>
+          <a:bodyPr wrap="square" lIns="91440" tIns="45720" rIns="91440" bIns="45720" rtlCol="0" anchor="ctr"/>
+          <a:lstStyle/>
+          <a:p>
+            <a:pPr marL="0" indent="0">
+              <a:buNone/>
+            </a:pPr>
+            <a:r>
+              <a:rPr lang="es-ES" sz="950" b="1" dirty="0">
+                <a:solidFill>
+                  <a:srgbClr val="D4A843"/>
+                </a:solidFill>
+                <a:latin typeface="Calibri" pitchFamily="34" charset="0"/>
+              </a:rPr>
+              <a:t>📊  Comparativa de modelos — Métricas sobre conjunto de TEST</a:t>
+            </a:r>
+          </a:p>
+        </p:txBody>
+      </p:sp>
+      <p:pic>
+        <p:nvPicPr>
+          <p:cNvPr id="6" name="TablaMetricas"/>
+          <p:cNvPicPr>
+            <a:picLocks noChangeAspect="1"/>
+          </p:cNvPicPr>
+          <p:nvPr/>
+        </p:nvPicPr>
+        <p:blipFill>
+          <a:blip r:embed="rId2"/>
+          <a:stretch>
+            <a:fillRect/>
+          </a:stretch>
+        </p:blipFill>
+        <p:spPr>
+          <a:xfrm>
+            <a:off x="182880" y="1097280"/>
+            <a:ext cx="5486400" cy="1554480"/>
+          </a:xfrm>
+          <a:prstGeom prst="rect">
+            <a:avLst/>
+          </a:prstGeom>
+          <a:noFill/>
+          <a:ln/>
+        </p:spPr>
+      </p:pic>
+      <p:sp>
+        <p:nvSpPr>
+          <p:cNvPr id="7" name="WinnerBox"/>
+          <p:cNvSpPr/>
+          <p:nvPr/>
+        </p:nvSpPr>
+        <p:spPr>
+          <a:xfrm>
+            <a:off x="5852880" y="868680"/>
+            <a:ext cx="3108960" cy="1783080"/>
+          </a:xfrm>
+          <a:prstGeom prst="rect">
+            <a:avLst/>
+          </a:prstGeom>
+          <a:solidFill>
+            <a:srgbClr val="1E3A5F"/>
+          </a:solidFill>
+          <a:ln>
+            <a:solidFill>
+              <a:srgbClr val="16A34A"/>
+            </a:solidFill>
+          </a:ln>
+        </p:spPr>
+        <p:txBody>
+          <a:bodyPr wrap="square" lIns="182880" tIns="91440" rIns="182880" bIns="91440" rtlCol="0" anchor="ctr"/>
+          <a:lstStyle/>
+          <a:p>
+            <a:pPr marL="0" indent="0">
+              <a:buNone/>
+            </a:pPr>
+            <a:r>
+              <a:rPr lang="es-ES" sz="1050" b="1" dirty="0">
+                <a:solidFill>
+                  <a:srgbClr val="16A34A"/>
+                </a:solidFill>
+                <a:latin typeface="Calibri" pitchFamily="34" charset="0"/>
+              </a:rPr>
+              <a:t>🏆  Mejor modelo: Bosque Aleatorio</a:t>
+            </a:r>
+          </a:p>
+          <a:p>
+            <a:pPr marL="0" indent="0">
+              <a:buNone/>
+            </a:pPr>
+            <a:r>
+              <a:rPr lang="es-ES" sz="800" dirty="0">
+                <a:latin typeface="Calibri" pitchFamily="34" charset="0"/>
+              </a:rPr>
+              <a:t> </a:t>
+            </a:r>
+          </a:p>
+          <a:p>
+            <a:pPr marL="0" indent="0">
+              <a:buNone/>
+            </a:pPr>
+            <a:r>
+              <a:rPr lang="es-ES" sz="1000" b="1" dirty="0">
+                <a:solidFill>
+                  <a:srgbClr val="D4A843"/>
+                </a:solidFill>
+                <a:latin typeface="Calibri" pitchFamily="34" charset="0"/>
+              </a:rPr>
+              <a:t>R²</a:t>
+            </a:r>
+            <a:r>
+              <a:rPr lang="es-ES" sz="900" dirty="0">
+                <a:solidFill>
+                  <a:srgbClr val="CBD5E1"/>
+                </a:solidFill>
+                <a:latin typeface="Calibri" pitchFamily="34" charset="0"/>
+              </a:rPr>
+              <a:t>  =  </a:t>
+            </a:r>
+            <a:r>
+              <a:rPr lang="es-ES" sz="2200" b="1" dirty="0">
+                <a:solidFill>
+                  <a:srgbClr val="FFFFFF"/>
+                </a:solidFill>
+                <a:latin typeface="Calibri" pitchFamily="34" charset="0"/>
+              </a:rPr>
+              <a:t>0.8779</a:t>
+            </a:r>
+          </a:p>
+          <a:p>
+            <a:pPr marL="0" indent="0">
+              <a:buNone/>
+            </a:pPr>
+            <a:r>
+              <a:rPr lang="es-ES" sz="1000" b="1" dirty="0">
+                <a:solidFill>
+                  <a:srgbClr val="D4A843"/>
+                </a:solidFill>
+                <a:latin typeface="Calibri" pitchFamily="34" charset="0"/>
+              </a:rPr>
+              <a:t>MAE</a:t>
+            </a:r>
+            <a:r>
+              <a:rPr lang="es-ES" sz="900" dirty="0">
+                <a:solidFill>
+                  <a:srgbClr val="CBD5E1"/>
+                </a:solidFill>
+                <a:latin typeface="Calibri" pitchFamily="34" charset="0"/>
+              </a:rPr>
+              <a:t>  =  </a:t>
+            </a:r>
+            <a:r>
+              <a:rPr lang="es-ES" sz="1800" b="1" dirty="0">
+                <a:solidFill>
+                  <a:srgbClr val="F4F8FC"/>
+                </a:solidFill>
+                <a:latin typeface="Calibri" pitchFamily="34" charset="0"/>
+              </a:rPr>
+              <a:t>19.45 €</a:t>
+            </a:r>
+          </a:p>
+          <a:p>
+            <a:pPr marL="0" indent="0">
+              <a:buNone/>
+            </a:pPr>
+            <a:r>
+              <a:rPr lang="es-ES" sz="1000" b="1" dirty="0">
+                <a:solidFill>
+                  <a:srgbClr val="D4A843"/>
+                </a:solidFill>
+                <a:latin typeface="Calibri" pitchFamily="34" charset="0"/>
+              </a:rPr>
+              <a:t>RMSE</a:t>
+            </a:r>
+            <a:r>
+              <a:rPr lang="es-ES" sz="900" dirty="0">
+                <a:solidFill>
+                  <a:srgbClr val="CBD5E1"/>
+                </a:solidFill>
+                <a:latin typeface="Calibri" pitchFamily="34" charset="0"/>
+              </a:rPr>
+              <a:t>  =  </a:t>
+            </a:r>
+            <a:r>
+              <a:rPr lang="es-ES" sz="1800" b="1" dirty="0">
+                <a:solidFill>
+                  <a:srgbClr val="F4F8FC"/>
+                </a:solidFill>
+                <a:latin typeface="Calibri" pitchFamily="34" charset="0"/>
+              </a:rPr>
+              <a:t>33.18 €</a:t>
+            </a:r>
+          </a:p>
+          <a:p>
+            <a:pPr marL="0" indent="0">
+              <a:buNone/>
+            </a:pPr>
+            <a:r>
+              <a:rPr lang="es-ES" sz="800" dirty="0">
+                <a:latin typeface="Calibri" pitchFamily="34" charset="0"/>
+              </a:rPr>
+              <a:t> </a:t>
+            </a:r>
+          </a:p>
+          <a:p>
+            <a:pPr marL="0" indent="0">
+              <a:buNone/>
+            </a:pPr>
+            <a:r>
+              <a:rPr lang="es-ES" sz="900" dirty="0">
+                <a:solidFill>
+                  <a:srgbClr val="CBD5E1"/>
+                </a:solidFill>
+                <a:latin typeface="Calibri" pitchFamily="34" charset="0"/>
+              </a:rPr>
+              <a:t>Explica el 87,8% de la varianza del precio.
+Error medio de ±19,45€ sobre el precio real.</a:t>
+            </a:r>
+          </a:p>
+        </p:txBody>
+      </p:sp>
+      <p:sp>
+        <p:nvSpPr>
+          <p:cNvPr id="8" name="LblDist"/>
+          <p:cNvSpPr/>
+          <p:nvPr/>
+        </p:nvSpPr>
+        <p:spPr>
+          <a:xfrm>
+            <a:off x="182880" y="2743200"/>
+            <a:ext cx="4921383" cy="228600"/>
+          </a:xfrm>
+          <a:prstGeom prst="rect">
+            <a:avLst/>
+          </a:prstGeom>
+          <a:solidFill>
+            <a:srgbClr val="1F5C40"/>
+          </a:solidFill>
+          <a:ln/>
+        </p:spPr>
+        <p:txBody>
+          <a:bodyPr wrap="square" lIns="91440" tIns="45720" rIns="91440" bIns="45720" rtlCol="0" anchor="ctr"/>
+          <a:lstStyle/>
+          <a:p>
+            <a:pPr marL="0" indent="0">
+              <a:buNone/>
+            </a:pPr>
+            <a:r>
+              <a:rPr lang="es-ES" sz="950" b="1" dirty="0">
+                <a:solidFill>
+                  <a:srgbClr val="D4A843"/>
+                </a:solidFill>
+                <a:latin typeface="Calibri" pitchFamily="34" charset="0"/>
+              </a:rPr>
+              <a:t>📊  Distribución de categorías de chollo — Conjunto TEST (414.936 registros)</a:t>
+            </a:r>
+          </a:p>
+        </p:txBody>
+      </p:sp>
+      <p:pic>
+        <p:nvPicPr>
+          <p:cNvPr id="9" name="TablaDistrib"/>
+          <p:cNvPicPr>
+            <a:picLocks noChangeAspect="1"/>
+          </p:cNvPicPr>
+          <p:nvPr/>
+        </p:nvPicPr>
+        <p:blipFill>
+          <a:blip r:embed="rId3"/>
+          <a:stretch>
+            <a:fillRect/>
+          </a:stretch>
+        </p:blipFill>
+        <p:spPr>
+          <a:xfrm>
+            <a:off x="182880" y="2972880"/>
+            <a:ext cx="4921383" cy="1782000"/>
+          </a:xfrm>
+          <a:prstGeom prst="rect">
+            <a:avLst/>
+          </a:prstGeom>
+          <a:noFill/>
+          <a:ln/>
+        </p:spPr>
+      </p:pic>
+      <p:sp>
+        <p:nvSpPr>
+          <p:cNvPr id="10" name="InsightBox"/>
+          <p:cNvSpPr/>
+          <p:nvPr/>
+        </p:nvSpPr>
+        <p:spPr>
+          <a:xfrm>
+            <a:off x="5424985" y="2743200"/>
+            <a:ext cx="3536855" cy="2011680"/>
+          </a:xfrm>
+          <a:prstGeom prst="rect">
+            <a:avLst/>
+          </a:prstGeom>
+          <a:solidFill>
+            <a:srgbClr val="1E3A5F"/>
+          </a:solidFill>
+          <a:ln>
+            <a:solidFill>
+              <a:srgbClr val="2A5080"/>
+            </a:solidFill>
+          </a:ln>
+        </p:spPr>
+        <p:txBody>
+          <a:bodyPr wrap="square" lIns="182880" tIns="182880" rIns="182880" bIns="91440" rtlCol="0" anchor="t"/>
+          <a:lstStyle/>
+          <a:p>
+            <a:pPr marL="0" indent="0">
+              <a:buNone/>
+            </a:pPr>
+            <a:r>
+              <a:rPr lang="es-ES" sz="1000" b="1" dirty="0">
+                <a:solidFill>
+                  <a:srgbClr val="D4A843"/>
+                </a:solidFill>
+                <a:latin typeface="Calibri" pitchFamily="34" charset="0"/>
+              </a:rPr>
+              <a:t>💡  Interpretación:</a:t>
+            </a:r>
+          </a:p>
+          <a:p>
+            <a:pPr marL="0" indent="0">
+              <a:buNone/>
+            </a:pPr>
+            <a:r>
+              <a:rPr lang="es-ES" sz="800" dirty="0">
+                <a:latin typeface="Calibri" pitchFamily="34" charset="0"/>
+              </a:rPr>
+              <a:t> </a:t>
+            </a:r>
+          </a:p>
+          <a:p>
+            <a:pPr marL="0" indent="0">
+              <a:buNone/>
+            </a:pPr>
+            <a:r>
+              <a:rPr lang="es-ES" sz="900" b="1" dirty="0">
+                <a:solidFill>
+                  <a:srgbClr val="16A34A"/>
+                </a:solidFill>
+                <a:latin typeface="Calibri" pitchFamily="34" charset="0"/>
+              </a:rPr>
+              <a:t>Chollos detectados</a:t>
+            </a:r>
+          </a:p>
+          <a:p>
+            <a:pPr marL="0" indent="0">
+              <a:buNone/>
+            </a:pPr>
+            <a:r>
+              <a:rPr lang="es-ES" sz="850" dirty="0">
+                <a:solidFill>
+                  <a:srgbClr val="CBD5E1"/>
+                </a:solidFill>
+                <a:latin typeface="Calibri" pitchFamily="34" charset="0"/>
+              </a:rPr>
+              <a:t>chollo + super + híper-chollo</a:t>
+            </a:r>
+          </a:p>
+          <a:p>
+            <a:pPr marL="0" indent="0">
+              <a:buNone/>
+            </a:pPr>
+            <a:r>
+              <a:rPr lang="es-ES" sz="1300" b="1" dirty="0">
+                <a:solidFill>
+                  <a:srgbClr val="FFFFFF"/>
+                </a:solidFill>
+                <a:latin typeface="Calibri" pitchFamily="34" charset="0"/>
+              </a:rPr>
+              <a:t>= 206.006 registros</a:t>
+            </a:r>
+          </a:p>
+          <a:p>
+            <a:pPr marL="0" indent="0">
+              <a:buNone/>
+            </a:pPr>
+            <a:r>
+              <a:rPr lang="es-ES" sz="1000" b="1" dirty="0">
+                <a:solidFill>
+                  <a:srgbClr val="16A34A"/>
+                </a:solidFill>
+                <a:latin typeface="Calibri" pitchFamily="34" charset="0"/>
+              </a:rPr>
+              <a:t>= 49,9% del conjunto TEST</a:t>
+            </a:r>
+          </a:p>
+          <a:p>
+            <a:pPr marL="0" indent="0">
+              <a:buNone/>
+            </a:pPr>
+            <a:r>
+              <a:rPr lang="es-ES" sz="800" dirty="0">
+                <a:latin typeface="Calibri" pitchFamily="34" charset="0"/>
+              </a:rPr>
+              <a:t> </a:t>
+            </a:r>
+          </a:p>
+          <a:p>
+            <a:pPr marL="0" indent="0">
+              <a:buNone/>
+            </a:pPr>
+            <a:r>
+              <a:rPr lang="es-ES" sz="900" dirty="0">
+                <a:solidFill>
+                  <a:srgbClr val="CBD5E1"/>
+                </a:solidFill>
+                <a:latin typeface="Calibri" pitchFamily="34" charset="0"/>
+              </a:rPr>
+              <a:t>El modelo identifica correctamente
+casi 1 de cada 2 alojamientos
+como oportunidad de ahorro.</a:t>
+            </a:r>
+          </a:p>
+          <a:p>
+            <a:pPr marL="0" indent="0">
+              <a:buNone/>
+            </a:pPr>
+            <a:r>
+              <a:rPr lang="es-ES" sz="800" dirty="0">
+                <a:latin typeface="Calibri" pitchFamily="34" charset="0"/>
+              </a:rPr>
+              <a:t> </a:t>
+            </a:r>
+          </a:p>
+          <a:p>
+            <a:pPr marL="0" indent="0">
+              <a:buNone/>
+            </a:pPr>
+            <a:r>
+              <a:rPr lang="es-ES" sz="850" dirty="0">
+                <a:solidFill>
+                  <a:srgbClr val="8899AA"/>
+                </a:solidFill>
+                <a:latin typeface="Calibri" pitchFamily="34" charset="0"/>
+              </a:rPr>
+              <a:t>Inflado + Normal = 207.930 (50.1%)</a:t>
+            </a:r>
+          </a:p>
+        </p:txBody>
+      </p:sp>
+      <p:sp>
+        <p:nvSpPr>
+          <p:cNvPr id="97" name="Footer"/>
+          <p:cNvSpPr/>
+          <p:nvPr/>
+        </p:nvSpPr>
+        <p:spPr>
+          <a:xfrm>
+            <a:off x="457200" y="4826520"/>
+            <a:ext cx="7772400" cy="200000"/>
+          </a:xfrm>
+          <a:prstGeom prst="rect">
+            <a:avLst/>
+          </a:prstGeom>
+          <a:noFill/>
+          <a:ln/>
+        </p:spPr>
+        <p:txBody>
+          <a:bodyPr wrap="square" lIns="0" tIns="0" rIns="0" bIns="0" rtlCol="0" anchor="ctr"/>
+          <a:lstStyle/>
+          <a:p>
+            <a:pPr marL="0" indent="0">
+              <a:buNone/>
+            </a:pPr>
+            <a:r>
+              <a:rPr lang="es-ES" sz="800" dirty="0">
+                <a:solidFill>
+                  <a:srgbClr val="4A6080"/>
+                </a:solidFill>
+                <a:latin typeface="Calibri" pitchFamily="34" charset="0"/>
+              </a:rPr>
+              <a:t>TFG · Detector de Chollos en Andalucía · Mario Jiménez · Universidad de Sevilla</a:t>
+            </a:r>
+          </a:p>
+        </p:txBody>
+      </p:sp>
+      <p:sp>
+        <p:nvSpPr>
+          <p:cNvPr id="98" name="PageNum"/>
+          <p:cNvSpPr/>
+          <p:nvPr/>
+        </p:nvSpPr>
+        <p:spPr>
+          <a:xfrm>
+            <a:off x="8594640" y="4754880"/>
+            <a:ext cx="365760" cy="228600"/>
+          </a:xfrm>
+          <a:prstGeom prst="rect">
+            <a:avLst/>
+          </a:prstGeom>
+          <a:noFill/>
+          <a:ln/>
+        </p:spPr>
+        <p:txBody>
+          <a:bodyPr wrap="square" lIns="0" tIns="0" rIns="0" bIns="0" rtlCol="0" anchor="ctr"/>
+          <a:lstStyle/>
+          <a:p>
+            <a:pPr marL="0" indent="0">
+              <a:buNone/>
+            </a:pPr>
+            <a:endParaRPr lang="es-ES" sz="900" dirty="0">
+              <a:solidFill>
+                <a:srgbClr val="4A6080"/>
+              </a:solidFill>
+              <a:latin typeface="Calibri" pitchFamily="34" charset="0"/>
+            </a:endParaRPr>
+          </a:p>
+        </p:txBody>
+      </p:sp>
+    </p:spTree>
+  </p:cSld>
+  <p:clrMapOvr>
+    <a:masterClrMapping/>
+  </p:clrMapOvr>
+</p:sld>
+</file>
+
+<file path=ppt/slides/slide21.xml><?xml version="1.0" encoding="utf-8"?>
+<p:sld xmlns:a="http://schemas.openxmlformats.org/drawingml/2006/main" xmlns:r="http://schemas.openxmlformats.org/officeDocument/2006/relationships" xmlns:p="http://schemas.openxmlformats.org/presentationml/2006/main">
   <p:cSld name="Slide 8">
     <p:bg>
       <p:bgPr>
@@ -15863,7 +16495,7 @@
 </p:sld>
 </file>
 
-<file path=ppt/slides/slide21.xml><?xml version="1.0" encoding="utf-8"?>
+<file path=ppt/slides/slide22.xml><?xml version="1.0" encoding="utf-8"?>
 <p:sld xmlns:a="http://schemas.openxmlformats.org/drawingml/2006/main" xmlns:r="http://schemas.openxmlformats.org/officeDocument/2006/relationships" xmlns:p="http://schemas.openxmlformats.org/presentationml/2006/main">
   <p:cSld>
     <p:bg>
@@ -17033,7 +17665,7 @@
 </p:sld>
 </file>
 
-<file path=ppt/slides/slide22.xml><?xml version="1.0" encoding="utf-8"?>
+<file path=ppt/slides/slide23.xml><?xml version="1.0" encoding="utf-8"?>
 <p:sld xmlns:a="http://schemas.openxmlformats.org/drawingml/2006/main" xmlns:r="http://schemas.openxmlformats.org/officeDocument/2006/relationships" xmlns:p="http://schemas.openxmlformats.org/presentationml/2006/main">
   <p:cSld name="Slide 13">
     <p:bg>
@@ -18053,7 +18685,7 @@
 </p:sld>
 </file>
 
-<file path=ppt/slides/slide23.xml><?xml version="1.0" encoding="utf-8"?>
+<file path=ppt/slides/slide24.xml><?xml version="1.0" encoding="utf-8"?>
 <p:sld xmlns:a="http://schemas.openxmlformats.org/drawingml/2006/main" xmlns:r="http://schemas.openxmlformats.org/officeDocument/2006/relationships" xmlns:p="http://schemas.openxmlformats.org/presentationml/2006/main">
   <p:cSld name="Slide 14">
     <p:bg>

</xml_diff>